<commit_message>
Add demo video and update presentation
</commit_message>
<xml_diff>
--- a/SpamGuard_проектная_презентация.pptx
+++ b/SpamGuard_проектная_презентация.pptx
@@ -2,32 +2,32 @@
 <file path=ppt/presentation.xml><?xml version="1.0" encoding="utf-8"?>
 <p:presentation xmlns:p="http://schemas.openxmlformats.org/presentationml/2006/main">
   <p:sldMasterIdLst>
-    <p:sldMasterId xmlns:r="http://schemas.openxmlformats.org/officeDocument/2006/relationships" id="2147483648" r:id="R1efafde4dafd4ba0"/>
+    <p:sldMasterId xmlns:r="http://schemas.openxmlformats.org/officeDocument/2006/relationships" id="2147483648" r:id="Ra40b9e35f4974167"/>
   </p:sldMasterIdLst>
   <p:notesMasterIdLst>
-    <p:notesMasterId xmlns:r="http://schemas.openxmlformats.org/officeDocument/2006/relationships" r:id="Rf82ee27b325640d3"/>
+    <p:notesMasterId xmlns:r="http://schemas.openxmlformats.org/officeDocument/2006/relationships" r:id="R753743a03cb74e0a"/>
   </p:notesMasterIdLst>
   <p:sldIdLst>
-    <p:sldId xmlns:r="http://schemas.openxmlformats.org/officeDocument/2006/relationships" id="256" r:id="Rcdd04d61d26d495f"/>
-    <p:sldId xmlns:r="http://schemas.openxmlformats.org/officeDocument/2006/relationships" id="257" r:id="R4da25e1cd1b94c9f"/>
-    <p:sldId xmlns:r="http://schemas.openxmlformats.org/officeDocument/2006/relationships" id="258" r:id="R90c2725b6ada4acd"/>
-    <p:sldId xmlns:r="http://schemas.openxmlformats.org/officeDocument/2006/relationships" id="259" r:id="R54fb9e09b1ed4c63"/>
-    <p:sldId xmlns:r="http://schemas.openxmlformats.org/officeDocument/2006/relationships" id="260" r:id="R375f056013f44ee3"/>
-    <p:sldId xmlns:r="http://schemas.openxmlformats.org/officeDocument/2006/relationships" id="261" r:id="Re2d32f1b84754486"/>
-    <p:sldId xmlns:r="http://schemas.openxmlformats.org/officeDocument/2006/relationships" id="262" r:id="R91d86efdd33647d8"/>
-    <p:sldId xmlns:r="http://schemas.openxmlformats.org/officeDocument/2006/relationships" id="263" r:id="Rf5ae667b1cfe4109"/>
-    <p:sldId xmlns:r="http://schemas.openxmlformats.org/officeDocument/2006/relationships" id="264" r:id="Rde0e4b128ee64cab"/>
-    <p:sldId xmlns:r="http://schemas.openxmlformats.org/officeDocument/2006/relationships" id="265" r:id="R85403b997715439c"/>
-    <p:sldId xmlns:r="http://schemas.openxmlformats.org/officeDocument/2006/relationships" id="266" r:id="Rbd8f12282999409a"/>
-    <p:sldId xmlns:r="http://schemas.openxmlformats.org/officeDocument/2006/relationships" id="267" r:id="Rf7ddaf6af82d44d2"/>
-    <p:sldId xmlns:r="http://schemas.openxmlformats.org/officeDocument/2006/relationships" id="268" r:id="Ra92cc670f4c24ce1"/>
-    <p:sldId xmlns:r="http://schemas.openxmlformats.org/officeDocument/2006/relationships" id="269" r:id="R4d61d22e97114f4a"/>
-    <p:sldId xmlns:r="http://schemas.openxmlformats.org/officeDocument/2006/relationships" id="270" r:id="R2d25117aef5b4360"/>
-    <p:sldId xmlns:r="http://schemas.openxmlformats.org/officeDocument/2006/relationships" id="271" r:id="Rbda4c76356d04889"/>
-    <p:sldId xmlns:r="http://schemas.openxmlformats.org/officeDocument/2006/relationships" id="272" r:id="R3548bdbb5dc5416c"/>
-    <p:sldId xmlns:r="http://schemas.openxmlformats.org/officeDocument/2006/relationships" id="273" r:id="R2d05f2dba758411c"/>
-    <p:sldId xmlns:r="http://schemas.openxmlformats.org/officeDocument/2006/relationships" id="274" r:id="Rc52d32b89ef34983"/>
-    <p:sldId xmlns:r="http://schemas.openxmlformats.org/officeDocument/2006/relationships" id="275" r:id="Rb60c9839ab924322"/>
+    <p:sldId xmlns:r="http://schemas.openxmlformats.org/officeDocument/2006/relationships" id="256" r:id="R175b5d08f2974941"/>
+    <p:sldId xmlns:r="http://schemas.openxmlformats.org/officeDocument/2006/relationships" id="257" r:id="Rc4dee8d26d8d4da3"/>
+    <p:sldId xmlns:r="http://schemas.openxmlformats.org/officeDocument/2006/relationships" id="258" r:id="R4a1275c9dbce4fb4"/>
+    <p:sldId xmlns:r="http://schemas.openxmlformats.org/officeDocument/2006/relationships" id="259" r:id="Re35b9732ed374182"/>
+    <p:sldId xmlns:r="http://schemas.openxmlformats.org/officeDocument/2006/relationships" id="260" r:id="R5ec3226450084441"/>
+    <p:sldId xmlns:r="http://schemas.openxmlformats.org/officeDocument/2006/relationships" id="261" r:id="Rda6f6528e86247df"/>
+    <p:sldId xmlns:r="http://schemas.openxmlformats.org/officeDocument/2006/relationships" id="262" r:id="R7d3c274fc5d94457"/>
+    <p:sldId xmlns:r="http://schemas.openxmlformats.org/officeDocument/2006/relationships" id="263" r:id="Rb4b22ccde7594a02"/>
+    <p:sldId xmlns:r="http://schemas.openxmlformats.org/officeDocument/2006/relationships" id="264" r:id="Rb42c583a77a04446"/>
+    <p:sldId xmlns:r="http://schemas.openxmlformats.org/officeDocument/2006/relationships" id="265" r:id="R53f370c050354f3d"/>
+    <p:sldId xmlns:r="http://schemas.openxmlformats.org/officeDocument/2006/relationships" id="266" r:id="Re3050d89e7c54814"/>
+    <p:sldId xmlns:r="http://schemas.openxmlformats.org/officeDocument/2006/relationships" id="267" r:id="Reefddf9a2f1f4e0a"/>
+    <p:sldId xmlns:r="http://schemas.openxmlformats.org/officeDocument/2006/relationships" id="268" r:id="R8f1bb5cd051f4fdd"/>
+    <p:sldId xmlns:r="http://schemas.openxmlformats.org/officeDocument/2006/relationships" id="269" r:id="Rd018fdcc144d4db5"/>
+    <p:sldId xmlns:r="http://schemas.openxmlformats.org/officeDocument/2006/relationships" id="270" r:id="Rde0e9487d63e44a2"/>
+    <p:sldId xmlns:r="http://schemas.openxmlformats.org/officeDocument/2006/relationships" id="271" r:id="Ra276049a33ce4d38"/>
+    <p:sldId xmlns:r="http://schemas.openxmlformats.org/officeDocument/2006/relationships" id="272" r:id="Rf203eebf08df43d5"/>
+    <p:sldId xmlns:r="http://schemas.openxmlformats.org/officeDocument/2006/relationships" id="273" r:id="R610a2205909e43ce"/>
+    <p:sldId xmlns:r="http://schemas.openxmlformats.org/officeDocument/2006/relationships" id="274" r:id="R0bdd8edf57274f46"/>
+    <p:sldId xmlns:r="http://schemas.openxmlformats.org/officeDocument/2006/relationships" id="275" r:id="R697c1cdaa6fe4571"/>
   </p:sldIdLst>
   <p:sldSz cx="12192000" cy="6858000"/>
   <p:notesSz cx="6858000" cy="9144000"/>
@@ -801,7 +801,7 @@
           </a:p>
           <a:p xmlns:a="http://schemas.openxmlformats.org/drawingml/2006/main">
             <a:r>
-              <a:t>- Данные зафиксированы 01.09.2026</a:t>
+              <a:t>- Данные рассчитаны на фиксированной выборке.</a:t>
             </a:r>
           </a:p>
         </p:txBody>
@@ -961,7 +961,7 @@
           </a:p>
           <a:p xmlns:a="http://schemas.openxmlformats.org/drawingml/2006/main">
             <a:r>
-              <a:t>- Фактический замер обучения/автотестов 01.09.2026: 23–26 с на текущем окружении</a:t>
+              <a:t>- Фактический замер обучения/автотестов: 23–26 с на текущем окружении</a:t>
             </a:r>
           </a:p>
         </p:txBody>
@@ -1041,7 +1041,7 @@
           </a:p>
           <a:p xmlns:a="http://schemas.openxmlformats.org/drawingml/2006/main">
             <a:r>
-              <a:t>- Test set фиксирован random_state=42; метрики рассчитаны 01.09.2026</a:t>
+              <a:t>- Test set фиксирован random_state=42; метрики рассчитаны на фиксированном разделении данных</a:t>
             </a:r>
           </a:p>
         </p:txBody>
@@ -1201,7 +1201,7 @@
           </a:p>
           <a:p xmlns:a="http://schemas.openxmlformats.org/drawingml/2006/main">
             <a:r>
-              <a:t>- Фактическая matrix=[[3203,40],[87,1638]]; by_language рассчитано 01.09.2026</a:t>
+              <a:t>- Фактическая matrix=[[3203,40],[87,1638]]; by_language рассчитано на отложенной выборке</a:t>
             </a:r>
           </a:p>
         </p:txBody>
@@ -1276,7 +1276,7 @@
           </a:p>
           <a:p xmlns:a="http://schemas.openxmlformats.org/drawingml/2006/main">
             <a:r>
-              <a:t>- Автотесты: tests/test_model.py; запуск 01.09.2026 — OK, 4/4</a:t>
+              <a:t>- Автотесты: tests/test_model.py; результат запуска — OK, 4/4</a:t>
             </a:r>
           </a:p>
           <a:p xmlns:a="http://schemas.openxmlformats.org/drawingml/2006/main">
@@ -2089,7 +2089,7 @@
   </p:cSld>
   <p:clrMap bg1="lt1" tx1="dk1" bg2="lt2" tx2="dk2" accent1="accent1" accent2="accent2" accent3="accent3" accent4="accent4" accent5="accent5" accent6="accent6" hlink="hlink" folHlink="folHlink"/>
   <p:sldLayoutIdLst>
-    <p:sldLayoutId xmlns:r="http://schemas.openxmlformats.org/officeDocument/2006/relationships" id="2147483649" r:id="Ra7efb6b50748449c"/>
+    <p:sldLayoutId xmlns:r="http://schemas.openxmlformats.org/officeDocument/2006/relationships" id="2147483649" r:id="Rdb084107808e482e"/>
   </p:sldLayoutIdLst>
   <p:txStyles>
     <p:titleStyle>
@@ -2940,6 +2940,7 @@
           <a:lstStyle xmlns:a="http://schemas.openxmlformats.org/drawingml/2006/main"/>
           <a:p xmlns:a="http://schemas.openxmlformats.org/drawingml/2006/main">
             <a:pPr algn="l">
+              <a:buNone/>
               <a:defRPr sz="1050" b="1">
                 <a:solidFill>
                   <a:srgbClr val="3D8DFF"/>
@@ -2992,6 +2993,7 @@
           <a:lstStyle xmlns:a="http://schemas.openxmlformats.org/drawingml/2006/main"/>
           <a:p xmlns:a="http://schemas.openxmlformats.org/drawingml/2006/main">
             <a:pPr algn="l">
+              <a:buNone/>
               <a:defRPr sz="4350" b="1">
                 <a:solidFill>
                   <a:srgbClr val="111318"/>
@@ -3044,6 +3046,7 @@
           <a:lstStyle xmlns:a="http://schemas.openxmlformats.org/drawingml/2006/main"/>
           <a:p xmlns:a="http://schemas.openxmlformats.org/drawingml/2006/main">
             <a:pPr algn="l">
+              <a:buNone/>
               <a:defRPr sz="2250" b="1">
                 <a:solidFill>
                   <a:srgbClr val="0E3A66"/>
@@ -3096,6 +3099,7 @@
           <a:lstStyle xmlns:a="http://schemas.openxmlformats.org/drawingml/2006/main"/>
           <a:p xmlns:a="http://schemas.openxmlformats.org/drawingml/2006/main">
             <a:pPr algn="l">
+              <a:buNone/>
               <a:defRPr sz="1500" b="0">
                 <a:solidFill>
                   <a:srgbClr val="5E6572"/>
@@ -3181,6 +3185,7 @@
           <a:lstStyle xmlns:a="http://schemas.openxmlformats.org/drawingml/2006/main"/>
           <a:p xmlns:a="http://schemas.openxmlformats.org/drawingml/2006/main">
             <a:pPr algn="ctr">
+              <a:buNone/>
               <a:defRPr sz="1050" b="1">
                 <a:solidFill>
                   <a:srgbClr val="2D9D78"/>
@@ -3266,6 +3271,7 @@
           <a:lstStyle xmlns:a="http://schemas.openxmlformats.org/drawingml/2006/main"/>
           <a:p xmlns:a="http://schemas.openxmlformats.org/drawingml/2006/main">
             <a:pPr algn="ctr">
+              <a:buNone/>
               <a:defRPr sz="1050" b="1">
                 <a:solidFill>
                   <a:srgbClr val="0E3A66"/>
@@ -3318,6 +3324,7 @@
           <a:lstStyle xmlns:a="http://schemas.openxmlformats.org/drawingml/2006/main"/>
           <a:p xmlns:a="http://schemas.openxmlformats.org/drawingml/2006/main">
             <a:pPr algn="l">
+              <a:buNone/>
               <a:defRPr sz="1350" b="0">
                 <a:solidFill>
                   <a:srgbClr val="5E6572"/>
@@ -3335,6 +3342,7 @@
           </a:p>
           <a:p xmlns:a="http://schemas.openxmlformats.org/drawingml/2006/main">
             <a:pPr algn="l">
+              <a:buNone/>
               <a:defRPr sz="1350" b="0">
                 <a:solidFill>
                   <a:srgbClr val="5E6572"/>
@@ -3418,14 +3426,14 @@
       </p:sp>
       <p:pic>
         <p:nvPicPr>
-          <p:cNvPr id="27" name=""/>
+          <p:cNvPr id="29" name=""/>
           <p:cNvPicPr>
             <a:picLocks xmlns:a="http://schemas.openxmlformats.org/drawingml/2006/main" noChangeAspect="1"/>
           </p:cNvPicPr>
           <p:nvPr/>
         </p:nvPicPr>
         <p:blipFill>
-          <a:blip xmlns:r="http://schemas.openxmlformats.org/officeDocument/2006/relationships" xmlns:a="http://schemas.openxmlformats.org/drawingml/2006/main" r:embed="Rba3492e105dc4418"/>
+          <a:blip xmlns:r="http://schemas.openxmlformats.org/officeDocument/2006/relationships" xmlns:a="http://schemas.openxmlformats.org/drawingml/2006/main" r:embed="Rca0dfb5f0579426c"/>
           <a:srcRect xmlns:a="http://schemas.openxmlformats.org/drawingml/2006/main" l="6320" t="0" r="6320" b="0"/>
           <a:stretch xmlns:a="http://schemas.openxmlformats.org/drawingml/2006/main">
             <a:fillRect l="0" t="0" r="0" b="0"/>
@@ -3443,58 +3451,6 @@
           </a:prstGeom>
         </p:spPr>
       </p:pic>
-      <p:sp>
-        <p:nvSpPr>
-          <p:cNvPr id="14" name="">
-            <a:extLst xmlns:a="http://schemas.openxmlformats.org/drawingml/2006/main">
-              <a:ext uri="{FF2B5EF4-FFF2-40B4-BE49-F238E27FC236}">
-                <a16:creationId xmlns:a16="http://schemas.microsoft.com/office/drawing/2014/main" id="{1326B359-A169-4652-BB12-95F7CBD6A842}"/>
-              </a:ext>
-            </a:extLst>
-          </p:cNvPr>
-          <p:cNvSpPr>
-            <a:spLocks xmlns:a="http://schemas.openxmlformats.org/drawingml/2006/main" noGrp="1"/>
-          </p:cNvSpPr>
-          <p:nvPr/>
-        </p:nvSpPr>
-        <p:spPr>
-          <a:xfrm xmlns:a="http://schemas.openxmlformats.org/drawingml/2006/main">
-            <a:off x="552450" y="6362700"/>
-            <a:ext cx="1714500" cy="190500"/>
-          </a:xfrm>
-          <a:prstGeom xmlns:a="http://schemas.openxmlformats.org/drawingml/2006/main" prst="rect">
-            <a:avLst/>
-          </a:prstGeom>
-          <a:noFill xmlns:a="http://schemas.openxmlformats.org/drawingml/2006/main"/>
-          <a:ln xmlns:a="http://schemas.openxmlformats.org/drawingml/2006/main" w="0">
-            <a:noFill/>
-            <a:prstDash val="solid"/>
-          </a:ln>
-        </p:spPr>
-        <p:txBody>
-          <a:bodyPr xmlns:a="http://schemas.openxmlformats.org/drawingml/2006/main" lIns="0" tIns="0" rIns="0" bIns="0" anchor="t">
-            <a:normAutofit fontScale="100000"/>
-          </a:bodyPr>
-          <a:lstStyle xmlns:a="http://schemas.openxmlformats.org/drawingml/2006/main"/>
-          <a:p xmlns:a="http://schemas.openxmlformats.org/drawingml/2006/main">
-            <a:pPr algn="l">
-              <a:defRPr sz="975" b="0">
-                <a:solidFill>
-                  <a:srgbClr val="8F96A3"/>
-                </a:solidFill>
-              </a:defRPr>
-            </a:pPr>
-            <a:r>
-              <a:rPr sz="975" b="0">
-                <a:solidFill>
-                  <a:srgbClr val="8F96A3"/>
-                </a:solidFill>
-              </a:rPr>
-              <a:t>01.09.2026</a:t>
-            </a:r>
-          </a:p>
-        </p:txBody>
-      </p:sp>
     </p:spTree>
     <p:extLst>
       <p:ext uri="{BB962C8B-B14F-4D97-AF65-F5344CB8AC3E}">
@@ -3559,6 +3515,7 @@
           <a:lstStyle xmlns:a="http://schemas.openxmlformats.org/drawingml/2006/main"/>
           <a:p xmlns:a="http://schemas.openxmlformats.org/drawingml/2006/main">
             <a:pPr algn="l">
+              <a:buNone/>
               <a:defRPr sz="975" b="1">
                 <a:solidFill>
                   <a:srgbClr val="3D8DFF"/>
@@ -3611,6 +3568,7 @@
           <a:lstStyle xmlns:a="http://schemas.openxmlformats.org/drawingml/2006/main"/>
           <a:p xmlns:a="http://schemas.openxmlformats.org/drawingml/2006/main">
             <a:pPr algn="l">
+              <a:buNone/>
               <a:defRPr sz="3000" b="1">
                 <a:solidFill>
                   <a:srgbClr val="111318"/>
@@ -3694,6 +3652,7 @@
           <a:lstStyle xmlns:a="http://schemas.openxmlformats.org/drawingml/2006/main"/>
           <a:p xmlns:a="http://schemas.openxmlformats.org/drawingml/2006/main">
             <a:pPr algn="r">
+              <a:buNone/>
               <a:defRPr sz="975" b="0">
                 <a:solidFill>
                   <a:srgbClr val="8F96A3"/>
@@ -3746,14 +3705,14 @@
       </p:sp>
       <p:pic>
         <p:nvPicPr>
-          <p:cNvPr id="27" name=""/>
+          <p:cNvPr id="29" name=""/>
           <p:cNvPicPr>
             <a:picLocks xmlns:a="http://schemas.openxmlformats.org/drawingml/2006/main" noChangeAspect="1"/>
           </p:cNvPicPr>
           <p:nvPr/>
         </p:nvPicPr>
         <p:blipFill>
-          <a:blip xmlns:r="http://schemas.openxmlformats.org/officeDocument/2006/relationships" xmlns:a="http://schemas.openxmlformats.org/drawingml/2006/main" r:embed="Refc41ad718b94032"/>
+          <a:blip xmlns:r="http://schemas.openxmlformats.org/officeDocument/2006/relationships" xmlns:a="http://schemas.openxmlformats.org/drawingml/2006/main" r:embed="R692a8d4044894508"/>
           <a:srcRect xmlns:a="http://schemas.openxmlformats.org/drawingml/2006/main" l="0" t="15882" r="0" b="15882"/>
           <a:stretch xmlns:a="http://schemas.openxmlformats.org/drawingml/2006/main">
             <a:fillRect l="0" t="0" r="0" b="0"/>
@@ -3806,6 +3765,7 @@
           <a:lstStyle xmlns:a="http://schemas.openxmlformats.org/drawingml/2006/main"/>
           <a:p xmlns:a="http://schemas.openxmlformats.org/drawingml/2006/main">
             <a:pPr algn="l">
+              <a:buNone/>
               <a:defRPr sz="1875" b="1">
                 <a:solidFill>
                   <a:srgbClr val="111318"/>
@@ -3889,6 +3849,7 @@
           <a:lstStyle xmlns:a="http://schemas.openxmlformats.org/drawingml/2006/main"/>
           <a:p xmlns:a="http://schemas.openxmlformats.org/drawingml/2006/main">
             <a:pPr algn="ctr">
+              <a:buNone/>
               <a:defRPr sz="1500" b="1">
                 <a:solidFill>
                   <a:srgbClr val="FFFFFF"/>
@@ -3941,6 +3902,7 @@
           <a:lstStyle xmlns:a="http://schemas.openxmlformats.org/drawingml/2006/main"/>
           <a:p xmlns:a="http://schemas.openxmlformats.org/drawingml/2006/main">
             <a:pPr algn="l">
+              <a:buNone/>
               <a:defRPr sz="1500" b="1">
                 <a:solidFill>
                   <a:srgbClr val="111318"/>
@@ -3993,6 +3955,7 @@
           <a:lstStyle xmlns:a="http://schemas.openxmlformats.org/drawingml/2006/main"/>
           <a:p xmlns:a="http://schemas.openxmlformats.org/drawingml/2006/main">
             <a:pPr algn="l">
+              <a:buNone/>
               <a:defRPr sz="1200" b="0">
                 <a:solidFill>
                   <a:srgbClr val="5E6572"/>
@@ -4076,6 +4039,7 @@
           <a:lstStyle xmlns:a="http://schemas.openxmlformats.org/drawingml/2006/main"/>
           <a:p xmlns:a="http://schemas.openxmlformats.org/drawingml/2006/main">
             <a:pPr algn="ctr">
+              <a:buNone/>
               <a:defRPr sz="1500" b="1">
                 <a:solidFill>
                   <a:srgbClr val="FFFFFF"/>
@@ -4128,6 +4092,7 @@
           <a:lstStyle xmlns:a="http://schemas.openxmlformats.org/drawingml/2006/main"/>
           <a:p xmlns:a="http://schemas.openxmlformats.org/drawingml/2006/main">
             <a:pPr algn="l">
+              <a:buNone/>
               <a:defRPr sz="1500" b="1">
                 <a:solidFill>
                   <a:srgbClr val="111318"/>
@@ -4180,6 +4145,7 @@
           <a:lstStyle xmlns:a="http://schemas.openxmlformats.org/drawingml/2006/main"/>
           <a:p xmlns:a="http://schemas.openxmlformats.org/drawingml/2006/main">
             <a:pPr algn="l">
+              <a:buNone/>
               <a:defRPr sz="1200" b="0">
                 <a:solidFill>
                   <a:srgbClr val="5E6572"/>
@@ -4263,6 +4229,7 @@
           <a:lstStyle xmlns:a="http://schemas.openxmlformats.org/drawingml/2006/main"/>
           <a:p xmlns:a="http://schemas.openxmlformats.org/drawingml/2006/main">
             <a:pPr algn="ctr">
+              <a:buNone/>
               <a:defRPr sz="1500" b="1">
                 <a:solidFill>
                   <a:srgbClr val="FFFFFF"/>
@@ -4315,6 +4282,7 @@
           <a:lstStyle xmlns:a="http://schemas.openxmlformats.org/drawingml/2006/main"/>
           <a:p xmlns:a="http://schemas.openxmlformats.org/drawingml/2006/main">
             <a:pPr algn="l">
+              <a:buNone/>
               <a:defRPr sz="1500" b="1">
                 <a:solidFill>
                   <a:srgbClr val="111318"/>
@@ -4367,6 +4335,7 @@
           <a:lstStyle xmlns:a="http://schemas.openxmlformats.org/drawingml/2006/main"/>
           <a:p xmlns:a="http://schemas.openxmlformats.org/drawingml/2006/main">
             <a:pPr algn="l">
+              <a:buNone/>
               <a:defRPr sz="1200" b="0">
                 <a:solidFill>
                   <a:srgbClr val="5E6572"/>
@@ -4452,6 +4421,7 @@
           <a:lstStyle xmlns:a="http://schemas.openxmlformats.org/drawingml/2006/main"/>
           <a:p xmlns:a="http://schemas.openxmlformats.org/drawingml/2006/main">
             <a:pPr algn="ctr">
+              <a:buNone/>
               <a:defRPr sz="1275" b="1">
                 <a:solidFill>
                   <a:srgbClr val="FFFFFF"/>
@@ -4533,6 +4503,7 @@
           <a:lstStyle xmlns:a="http://schemas.openxmlformats.org/drawingml/2006/main"/>
           <a:p xmlns:a="http://schemas.openxmlformats.org/drawingml/2006/main">
             <a:pPr algn="l">
+              <a:buNone/>
               <a:defRPr sz="975" b="1">
                 <a:solidFill>
                   <a:srgbClr val="3D8DFF"/>
@@ -4585,6 +4556,7 @@
           <a:lstStyle xmlns:a="http://schemas.openxmlformats.org/drawingml/2006/main"/>
           <a:p xmlns:a="http://schemas.openxmlformats.org/drawingml/2006/main">
             <a:pPr algn="l">
+              <a:buNone/>
               <a:defRPr sz="3000" b="1">
                 <a:solidFill>
                   <a:srgbClr val="111318"/>
@@ -4668,6 +4640,7 @@
           <a:lstStyle xmlns:a="http://schemas.openxmlformats.org/drawingml/2006/main"/>
           <a:p xmlns:a="http://schemas.openxmlformats.org/drawingml/2006/main">
             <a:pPr algn="r">
+              <a:buNone/>
               <a:defRPr sz="975" b="0">
                 <a:solidFill>
                   <a:srgbClr val="8F96A3"/>
@@ -4720,6 +4693,7 @@
           <a:lstStyle xmlns:a="http://schemas.openxmlformats.org/drawingml/2006/main"/>
           <a:p xmlns:a="http://schemas.openxmlformats.org/drawingml/2006/main">
             <a:pPr algn="l">
+              <a:buNone/>
               <a:defRPr sz="1875" b="1">
                 <a:solidFill>
                   <a:srgbClr val="111318"/>
@@ -4838,6 +4812,7 @@
           <a:lstStyle xmlns:a="http://schemas.openxmlformats.org/drawingml/2006/main"/>
           <a:p xmlns:a="http://schemas.openxmlformats.org/drawingml/2006/main">
             <a:pPr algn="l">
+              <a:buNone/>
               <a:defRPr sz="1575" b="1">
                 <a:solidFill>
                   <a:srgbClr val="111318"/>
@@ -4890,6 +4865,7 @@
           <a:lstStyle xmlns:a="http://schemas.openxmlformats.org/drawingml/2006/main"/>
           <a:p xmlns:a="http://schemas.openxmlformats.org/drawingml/2006/main">
             <a:pPr algn="l">
+              <a:buNone/>
               <a:defRPr sz="1200" b="0">
                 <a:solidFill>
                   <a:srgbClr val="5E6572"/>
@@ -5008,6 +4984,7 @@
           <a:lstStyle xmlns:a="http://schemas.openxmlformats.org/drawingml/2006/main"/>
           <a:p xmlns:a="http://schemas.openxmlformats.org/drawingml/2006/main">
             <a:pPr algn="l">
+              <a:buNone/>
               <a:defRPr sz="1575" b="1">
                 <a:solidFill>
                   <a:srgbClr val="111318"/>
@@ -5060,6 +5037,7 @@
           <a:lstStyle xmlns:a="http://schemas.openxmlformats.org/drawingml/2006/main"/>
           <a:p xmlns:a="http://schemas.openxmlformats.org/drawingml/2006/main">
             <a:pPr algn="l">
+              <a:buNone/>
               <a:defRPr sz="1200" b="0">
                 <a:solidFill>
                   <a:srgbClr val="5E6572"/>
@@ -5178,6 +5156,7 @@
           <a:lstStyle xmlns:a="http://schemas.openxmlformats.org/drawingml/2006/main"/>
           <a:p xmlns:a="http://schemas.openxmlformats.org/drawingml/2006/main">
             <a:pPr algn="l">
+              <a:buNone/>
               <a:defRPr sz="1575" b="1">
                 <a:solidFill>
                   <a:srgbClr val="111318"/>
@@ -5230,6 +5209,7 @@
           <a:lstStyle xmlns:a="http://schemas.openxmlformats.org/drawingml/2006/main"/>
           <a:p xmlns:a="http://schemas.openxmlformats.org/drawingml/2006/main">
             <a:pPr algn="l">
+              <a:buNone/>
               <a:defRPr sz="1200" b="0">
                 <a:solidFill>
                   <a:srgbClr val="5E6572"/>
@@ -5282,14 +5262,14 @@
       </p:sp>
       <p:pic>
         <p:nvPicPr>
-          <p:cNvPr id="41" name=""/>
+          <p:cNvPr id="43" name=""/>
           <p:cNvPicPr>
             <a:picLocks xmlns:a="http://schemas.openxmlformats.org/drawingml/2006/main" noChangeAspect="1"/>
           </p:cNvPicPr>
           <p:nvPr/>
         </p:nvPicPr>
         <p:blipFill>
-          <a:blip xmlns:r="http://schemas.openxmlformats.org/officeDocument/2006/relationships" xmlns:a="http://schemas.openxmlformats.org/drawingml/2006/main" r:embed="Rc45e3483e8ff481e"/>
+          <a:blip xmlns:r="http://schemas.openxmlformats.org/officeDocument/2006/relationships" xmlns:a="http://schemas.openxmlformats.org/drawingml/2006/main" r:embed="R6b9537d7b48e460d"/>
           <a:srcRect xmlns:a="http://schemas.openxmlformats.org/drawingml/2006/main" l="0" t="8365" r="0" b="8365"/>
           <a:stretch xmlns:a="http://schemas.openxmlformats.org/drawingml/2006/main">
             <a:fillRect l="0" t="0" r="0" b="0"/>
@@ -5375,6 +5355,7 @@
           <a:lstStyle xmlns:a="http://schemas.openxmlformats.org/drawingml/2006/main"/>
           <a:p xmlns:a="http://schemas.openxmlformats.org/drawingml/2006/main">
             <a:pPr algn="ctr">
+              <a:buNone/>
               <a:defRPr sz="2250" b="1">
                 <a:solidFill>
                   <a:srgbClr val="FFFFFF"/>
@@ -5427,6 +5408,7 @@
           <a:lstStyle xmlns:a="http://schemas.openxmlformats.org/drawingml/2006/main"/>
           <a:p xmlns:a="http://schemas.openxmlformats.org/drawingml/2006/main">
             <a:pPr algn="ctr">
+              <a:buNone/>
               <a:defRPr sz="900" b="1">
                 <a:solidFill>
                   <a:srgbClr val="6DCBF4"/>
@@ -5508,6 +5490,7 @@
           <a:lstStyle xmlns:a="http://schemas.openxmlformats.org/drawingml/2006/main"/>
           <a:p xmlns:a="http://schemas.openxmlformats.org/drawingml/2006/main">
             <a:pPr algn="l">
+              <a:buNone/>
               <a:defRPr sz="975" b="1">
                 <a:solidFill>
                   <a:srgbClr val="3D8DFF"/>
@@ -5560,6 +5543,7 @@
           <a:lstStyle xmlns:a="http://schemas.openxmlformats.org/drawingml/2006/main"/>
           <a:p xmlns:a="http://schemas.openxmlformats.org/drawingml/2006/main">
             <a:pPr algn="l">
+              <a:buNone/>
               <a:defRPr sz="3000" b="1">
                 <a:solidFill>
                   <a:srgbClr val="111318"/>
@@ -5643,6 +5627,7 @@
           <a:lstStyle xmlns:a="http://schemas.openxmlformats.org/drawingml/2006/main"/>
           <a:p xmlns:a="http://schemas.openxmlformats.org/drawingml/2006/main">
             <a:pPr algn="r">
+              <a:buNone/>
               <a:defRPr sz="975" b="0">
                 <a:solidFill>
                   <a:srgbClr val="8F96A3"/>
@@ -5761,6 +5746,7 @@
           <a:lstStyle xmlns:a="http://schemas.openxmlformats.org/drawingml/2006/main"/>
           <a:p xmlns:a="http://schemas.openxmlformats.org/drawingml/2006/main">
             <a:pPr algn="l">
+              <a:buNone/>
               <a:defRPr sz="1575" b="1">
                 <a:solidFill>
                   <a:srgbClr val="111318"/>
@@ -5813,6 +5799,7 @@
           <a:lstStyle xmlns:a="http://schemas.openxmlformats.org/drawingml/2006/main"/>
           <a:p xmlns:a="http://schemas.openxmlformats.org/drawingml/2006/main">
             <a:pPr algn="l">
+              <a:buNone/>
               <a:defRPr sz="1275" b="0">
                 <a:solidFill>
                   <a:srgbClr val="5E6572"/>
@@ -5830,6 +5817,7 @@
           </a:p>
           <a:p xmlns:a="http://schemas.openxmlformats.org/drawingml/2006/main">
             <a:pPr algn="l">
+              <a:buNone/>
               <a:defRPr sz="1275" b="0">
                 <a:solidFill>
                   <a:srgbClr val="5E6572"/>
@@ -5847,6 +5835,7 @@
           </a:p>
           <a:p xmlns:a="http://schemas.openxmlformats.org/drawingml/2006/main">
             <a:pPr algn="l">
+              <a:buNone/>
               <a:defRPr sz="1275" b="0">
                 <a:solidFill>
                   <a:srgbClr val="5E6572"/>
@@ -5965,6 +5954,7 @@
           <a:lstStyle xmlns:a="http://schemas.openxmlformats.org/drawingml/2006/main"/>
           <a:p xmlns:a="http://schemas.openxmlformats.org/drawingml/2006/main">
             <a:pPr algn="l">
+              <a:buNone/>
               <a:defRPr sz="1575" b="1">
                 <a:solidFill>
                   <a:srgbClr val="111318"/>
@@ -6017,6 +6007,7 @@
           <a:lstStyle xmlns:a="http://schemas.openxmlformats.org/drawingml/2006/main"/>
           <a:p xmlns:a="http://schemas.openxmlformats.org/drawingml/2006/main">
             <a:pPr algn="l">
+              <a:buNone/>
               <a:defRPr sz="1275" b="0">
                 <a:solidFill>
                   <a:srgbClr val="5E6572"/>
@@ -6034,6 +6025,7 @@
           </a:p>
           <a:p xmlns:a="http://schemas.openxmlformats.org/drawingml/2006/main">
             <a:pPr algn="l">
+              <a:buNone/>
               <a:defRPr sz="1275" b="0">
                 <a:solidFill>
                   <a:srgbClr val="5E6572"/>
@@ -6051,6 +6043,7 @@
           </a:p>
           <a:p xmlns:a="http://schemas.openxmlformats.org/drawingml/2006/main">
             <a:pPr algn="l">
+              <a:buNone/>
               <a:defRPr sz="1275" b="0">
                 <a:solidFill>
                   <a:srgbClr val="5E6572"/>
@@ -6169,6 +6162,7 @@
           <a:lstStyle xmlns:a="http://schemas.openxmlformats.org/drawingml/2006/main"/>
           <a:p xmlns:a="http://schemas.openxmlformats.org/drawingml/2006/main">
             <a:pPr algn="l">
+              <a:buNone/>
               <a:defRPr sz="1575" b="1">
                 <a:solidFill>
                   <a:srgbClr val="111318"/>
@@ -6221,6 +6215,7 @@
           <a:lstStyle xmlns:a="http://schemas.openxmlformats.org/drawingml/2006/main"/>
           <a:p xmlns:a="http://schemas.openxmlformats.org/drawingml/2006/main">
             <a:pPr algn="l">
+              <a:buNone/>
               <a:defRPr sz="1275" b="0">
                 <a:solidFill>
                   <a:srgbClr val="5E6572"/>
@@ -6238,6 +6233,7 @@
           </a:p>
           <a:p xmlns:a="http://schemas.openxmlformats.org/drawingml/2006/main">
             <a:pPr algn="l">
+              <a:buNone/>
               <a:defRPr sz="1275" b="0">
                 <a:solidFill>
                   <a:srgbClr val="5E6572"/>
@@ -6255,6 +6251,7 @@
           </a:p>
           <a:p xmlns:a="http://schemas.openxmlformats.org/drawingml/2006/main">
             <a:pPr algn="l">
+              <a:buNone/>
               <a:defRPr sz="1275" b="0">
                 <a:solidFill>
                   <a:srgbClr val="5E6572"/>
@@ -6340,6 +6337,7 @@
           <a:lstStyle xmlns:a="http://schemas.openxmlformats.org/drawingml/2006/main"/>
           <a:p xmlns:a="http://schemas.openxmlformats.org/drawingml/2006/main">
             <a:pPr algn="l">
+              <a:buNone/>
               <a:defRPr sz="1125" b="1">
                 <a:solidFill>
                   <a:srgbClr val="3D8DFF"/>
@@ -6392,6 +6390,7 @@
           <a:lstStyle xmlns:a="http://schemas.openxmlformats.org/drawingml/2006/main"/>
           <a:p xmlns:a="http://schemas.openxmlformats.org/drawingml/2006/main">
             <a:pPr algn="l">
+              <a:buNone/>
               <a:defRPr sz="1275" b="1">
                 <a:solidFill>
                   <a:srgbClr val="111318"/>
@@ -6444,6 +6443,7 @@
           <a:lstStyle xmlns:a="http://schemas.openxmlformats.org/drawingml/2006/main"/>
           <a:p xmlns:a="http://schemas.openxmlformats.org/drawingml/2006/main">
             <a:pPr algn="ctr">
+              <a:buNone/>
               <a:defRPr sz="1650" b="1">
                 <a:solidFill>
                   <a:srgbClr val="C8CDD5"/>
@@ -6529,6 +6529,7 @@
           <a:lstStyle xmlns:a="http://schemas.openxmlformats.org/drawingml/2006/main"/>
           <a:p xmlns:a="http://schemas.openxmlformats.org/drawingml/2006/main">
             <a:pPr algn="l">
+              <a:buNone/>
               <a:defRPr sz="1125" b="1">
                 <a:solidFill>
                   <a:srgbClr val="3D8DFF"/>
@@ -6581,6 +6582,7 @@
           <a:lstStyle xmlns:a="http://schemas.openxmlformats.org/drawingml/2006/main"/>
           <a:p xmlns:a="http://schemas.openxmlformats.org/drawingml/2006/main">
             <a:pPr algn="l">
+              <a:buNone/>
               <a:defRPr sz="1275" b="1">
                 <a:solidFill>
                   <a:srgbClr val="111318"/>
@@ -6633,6 +6635,7 @@
           <a:lstStyle xmlns:a="http://schemas.openxmlformats.org/drawingml/2006/main"/>
           <a:p xmlns:a="http://schemas.openxmlformats.org/drawingml/2006/main">
             <a:pPr algn="ctr">
+              <a:buNone/>
               <a:defRPr sz="1650" b="1">
                 <a:solidFill>
                   <a:srgbClr val="C8CDD5"/>
@@ -6718,6 +6721,7 @@
           <a:lstStyle xmlns:a="http://schemas.openxmlformats.org/drawingml/2006/main"/>
           <a:p xmlns:a="http://schemas.openxmlformats.org/drawingml/2006/main">
             <a:pPr algn="l">
+              <a:buNone/>
               <a:defRPr sz="1125" b="1">
                 <a:solidFill>
                   <a:srgbClr val="3D8DFF"/>
@@ -6770,6 +6774,7 @@
           <a:lstStyle xmlns:a="http://schemas.openxmlformats.org/drawingml/2006/main"/>
           <a:p xmlns:a="http://schemas.openxmlformats.org/drawingml/2006/main">
             <a:pPr algn="l">
+              <a:buNone/>
               <a:defRPr sz="1275" b="1">
                 <a:solidFill>
                   <a:srgbClr val="111318"/>
@@ -6822,6 +6827,7 @@
           <a:lstStyle xmlns:a="http://schemas.openxmlformats.org/drawingml/2006/main"/>
           <a:p xmlns:a="http://schemas.openxmlformats.org/drawingml/2006/main">
             <a:pPr algn="ctr">
+              <a:buNone/>
               <a:defRPr sz="1650" b="1">
                 <a:solidFill>
                   <a:srgbClr val="C8CDD5"/>
@@ -6907,6 +6913,7 @@
           <a:lstStyle xmlns:a="http://schemas.openxmlformats.org/drawingml/2006/main"/>
           <a:p xmlns:a="http://schemas.openxmlformats.org/drawingml/2006/main">
             <a:pPr algn="l">
+              <a:buNone/>
               <a:defRPr sz="1125" b="1">
                 <a:solidFill>
                   <a:srgbClr val="3D8DFF"/>
@@ -6959,6 +6966,7 @@
           <a:lstStyle xmlns:a="http://schemas.openxmlformats.org/drawingml/2006/main"/>
           <a:p xmlns:a="http://schemas.openxmlformats.org/drawingml/2006/main">
             <a:pPr algn="l">
+              <a:buNone/>
               <a:defRPr sz="1275" b="1">
                 <a:solidFill>
                   <a:srgbClr val="111318"/>
@@ -7011,6 +7019,7 @@
           <a:lstStyle xmlns:a="http://schemas.openxmlformats.org/drawingml/2006/main"/>
           <a:p xmlns:a="http://schemas.openxmlformats.org/drawingml/2006/main">
             <a:pPr algn="ctr">
+              <a:buNone/>
               <a:defRPr sz="1650" b="1">
                 <a:solidFill>
                   <a:srgbClr val="C8CDD5"/>
@@ -7096,6 +7105,7 @@
           <a:lstStyle xmlns:a="http://schemas.openxmlformats.org/drawingml/2006/main"/>
           <a:p xmlns:a="http://schemas.openxmlformats.org/drawingml/2006/main">
             <a:pPr algn="l">
+              <a:buNone/>
               <a:defRPr sz="1125" b="1">
                 <a:solidFill>
                   <a:srgbClr val="6DCBF4"/>
@@ -7148,6 +7158,7 @@
           <a:lstStyle xmlns:a="http://schemas.openxmlformats.org/drawingml/2006/main"/>
           <a:p xmlns:a="http://schemas.openxmlformats.org/drawingml/2006/main">
             <a:pPr algn="l">
+              <a:buNone/>
               <a:defRPr sz="1275" b="1">
                 <a:solidFill>
                   <a:srgbClr val="FFFFFF"/>
@@ -7233,6 +7244,7 @@
           <a:lstStyle xmlns:a="http://schemas.openxmlformats.org/drawingml/2006/main"/>
           <a:p xmlns:a="http://schemas.openxmlformats.org/drawingml/2006/main">
             <a:pPr algn="l">
+              <a:buNone/>
               <a:defRPr sz="1350" b="1">
                 <a:solidFill>
                   <a:srgbClr val="E3545B"/>
@@ -7285,6 +7297,7 @@
           <a:lstStyle xmlns:a="http://schemas.openxmlformats.org/drawingml/2006/main"/>
           <a:p xmlns:a="http://schemas.openxmlformats.org/drawingml/2006/main">
             <a:pPr algn="l">
+              <a:buNone/>
               <a:defRPr sz="1500" b="1">
                 <a:solidFill>
                   <a:srgbClr val="111318"/>
@@ -7366,6 +7379,7 @@
           <a:lstStyle xmlns:a="http://schemas.openxmlformats.org/drawingml/2006/main"/>
           <a:p xmlns:a="http://schemas.openxmlformats.org/drawingml/2006/main">
             <a:pPr algn="l">
+              <a:buNone/>
               <a:defRPr sz="975" b="1">
                 <a:solidFill>
                   <a:srgbClr val="3D8DFF"/>
@@ -7418,6 +7432,7 @@
           <a:lstStyle xmlns:a="http://schemas.openxmlformats.org/drawingml/2006/main"/>
           <a:p xmlns:a="http://schemas.openxmlformats.org/drawingml/2006/main">
             <a:pPr algn="l">
+              <a:buNone/>
               <a:defRPr sz="3000" b="1">
                 <a:solidFill>
                   <a:srgbClr val="111318"/>
@@ -7501,6 +7516,7 @@
           <a:lstStyle xmlns:a="http://schemas.openxmlformats.org/drawingml/2006/main"/>
           <a:p xmlns:a="http://schemas.openxmlformats.org/drawingml/2006/main">
             <a:pPr algn="r">
+              <a:buNone/>
               <a:defRPr sz="975" b="0">
                 <a:solidFill>
                   <a:srgbClr val="8F96A3"/>
@@ -7520,7 +7536,7 @@
       </p:sp>
       <p:graphicFrame>
         <p:nvGraphicFramePr>
-          <p:cNvPr id="21" name="Chart"/>
+          <p:cNvPr id="23" name="Chart"/>
           <p:cNvGraphicFramePr/>
           <p:nvPr/>
         </p:nvGraphicFramePr>
@@ -7530,7 +7546,7 @@
         </p:xfrm>
         <a:graphic xmlns:a="http://schemas.openxmlformats.org/drawingml/2006/main">
           <a:graphicData uri="http://schemas.openxmlformats.org/drawingml/2006/chart">
-            <c:chart xmlns:r="http://schemas.openxmlformats.org/officeDocument/2006/relationships" xmlns:c="http://schemas.openxmlformats.org/drawingml/2006/chart" r:id="Rd2234246bd23433d"/>
+            <c:chart xmlns:r="http://schemas.openxmlformats.org/officeDocument/2006/relationships" xmlns:c="http://schemas.openxmlformats.org/drawingml/2006/chart" r:id="R3d1d7c0fa0ea40d6"/>
           </a:graphicData>
         </a:graphic>
       </p:graphicFrame>
@@ -7569,6 +7585,7 @@
           <a:lstStyle xmlns:a="http://schemas.openxmlformats.org/drawingml/2006/main"/>
           <a:p xmlns:a="http://schemas.openxmlformats.org/drawingml/2006/main">
             <a:pPr algn="l">
+              <a:buNone/>
               <a:defRPr sz="3300" b="1">
                 <a:solidFill>
                   <a:srgbClr val="3D8DFF"/>
@@ -7621,6 +7638,7 @@
           <a:lstStyle xmlns:a="http://schemas.openxmlformats.org/drawingml/2006/main"/>
           <a:p xmlns:a="http://schemas.openxmlformats.org/drawingml/2006/main">
             <a:pPr algn="l">
+              <a:buNone/>
               <a:defRPr sz="1350" b="0">
                 <a:solidFill>
                   <a:srgbClr val="5E6572"/>
@@ -7739,6 +7757,7 @@
           <a:lstStyle xmlns:a="http://schemas.openxmlformats.org/drawingml/2006/main"/>
           <a:p xmlns:a="http://schemas.openxmlformats.org/drawingml/2006/main">
             <a:pPr algn="l">
+              <a:buNone/>
               <a:defRPr sz="1575" b="1">
                 <a:solidFill>
                   <a:srgbClr val="111318"/>
@@ -7791,6 +7810,7 @@
           <a:lstStyle xmlns:a="http://schemas.openxmlformats.org/drawingml/2006/main"/>
           <a:p xmlns:a="http://schemas.openxmlformats.org/drawingml/2006/main">
             <a:pPr algn="l">
+              <a:buNone/>
               <a:defRPr sz="1200" b="0">
                 <a:solidFill>
                   <a:srgbClr val="5E6572"/>
@@ -7909,6 +7929,7 @@
           <a:lstStyle xmlns:a="http://schemas.openxmlformats.org/drawingml/2006/main"/>
           <a:p xmlns:a="http://schemas.openxmlformats.org/drawingml/2006/main">
             <a:pPr algn="l">
+              <a:buNone/>
               <a:defRPr sz="1575" b="1">
                 <a:solidFill>
                   <a:srgbClr val="111318"/>
@@ -7961,6 +7982,7 @@
           <a:lstStyle xmlns:a="http://schemas.openxmlformats.org/drawingml/2006/main"/>
           <a:p xmlns:a="http://schemas.openxmlformats.org/drawingml/2006/main">
             <a:pPr algn="l">
+              <a:buNone/>
               <a:defRPr sz="1200" b="0">
                 <a:solidFill>
                   <a:srgbClr val="5E6572"/>
@@ -8013,6 +8035,7 @@
           <a:lstStyle xmlns:a="http://schemas.openxmlformats.org/drawingml/2006/main"/>
           <a:p xmlns:a="http://schemas.openxmlformats.org/drawingml/2006/main">
             <a:pPr algn="l">
+              <a:buNone/>
               <a:defRPr sz="1425" b="1">
                 <a:solidFill>
                   <a:srgbClr val="0E3A66"/>
@@ -8094,6 +8117,7 @@
           <a:lstStyle xmlns:a="http://schemas.openxmlformats.org/drawingml/2006/main"/>
           <a:p xmlns:a="http://schemas.openxmlformats.org/drawingml/2006/main">
             <a:pPr algn="l">
+              <a:buNone/>
               <a:defRPr sz="975" b="1">
                 <a:solidFill>
                   <a:srgbClr val="3D8DFF"/>
@@ -8146,6 +8170,7 @@
           <a:lstStyle xmlns:a="http://schemas.openxmlformats.org/drawingml/2006/main"/>
           <a:p xmlns:a="http://schemas.openxmlformats.org/drawingml/2006/main">
             <a:pPr algn="l">
+              <a:buNone/>
               <a:defRPr sz="3000" b="1">
                 <a:solidFill>
                   <a:srgbClr val="111318"/>
@@ -8229,6 +8254,7 @@
           <a:lstStyle xmlns:a="http://schemas.openxmlformats.org/drawingml/2006/main"/>
           <a:p xmlns:a="http://schemas.openxmlformats.org/drawingml/2006/main">
             <a:pPr algn="r">
+              <a:buNone/>
               <a:defRPr sz="975" b="0">
                 <a:solidFill>
                   <a:srgbClr val="8F96A3"/>
@@ -8314,6 +8340,7 @@
           <a:lstStyle xmlns:a="http://schemas.openxmlformats.org/drawingml/2006/main"/>
           <a:p xmlns:a="http://schemas.openxmlformats.org/drawingml/2006/main">
             <a:pPr algn="l">
+              <a:buNone/>
               <a:defRPr sz="1350" b="1">
                 <a:solidFill>
                   <a:srgbClr val="3D8DFF"/>
@@ -8366,6 +8393,7 @@
           <a:lstStyle xmlns:a="http://schemas.openxmlformats.org/drawingml/2006/main"/>
           <a:p xmlns:a="http://schemas.openxmlformats.org/drawingml/2006/main">
             <a:pPr algn="l">
+              <a:buNone/>
               <a:defRPr sz="1725" b="1">
                 <a:solidFill>
                   <a:srgbClr val="111318"/>
@@ -8418,6 +8446,7 @@
           <a:lstStyle xmlns:a="http://schemas.openxmlformats.org/drawingml/2006/main"/>
           <a:p xmlns:a="http://schemas.openxmlformats.org/drawingml/2006/main">
             <a:pPr algn="l">
+              <a:buNone/>
               <a:defRPr sz="1275" b="0">
                 <a:solidFill>
                   <a:srgbClr val="5E6572"/>
@@ -8435,6 +8464,7 @@
           </a:p>
           <a:p xmlns:a="http://schemas.openxmlformats.org/drawingml/2006/main">
             <a:pPr algn="l">
+              <a:buNone/>
               <a:defRPr sz="1275" b="0">
                 <a:solidFill>
                   <a:srgbClr val="5E6572"/>
@@ -8582,6 +8612,7 @@
           <a:lstStyle xmlns:a="http://schemas.openxmlformats.org/drawingml/2006/main"/>
           <a:p xmlns:a="http://schemas.openxmlformats.org/drawingml/2006/main">
             <a:pPr algn="l">
+              <a:buNone/>
               <a:defRPr sz="1350" b="1">
                 <a:solidFill>
                   <a:srgbClr val="3D8DFF"/>
@@ -8634,6 +8665,7 @@
           <a:lstStyle xmlns:a="http://schemas.openxmlformats.org/drawingml/2006/main"/>
           <a:p xmlns:a="http://schemas.openxmlformats.org/drawingml/2006/main">
             <a:pPr algn="l">
+              <a:buNone/>
               <a:defRPr sz="1725" b="1">
                 <a:solidFill>
                   <a:srgbClr val="111318"/>
@@ -8686,6 +8718,7 @@
           <a:lstStyle xmlns:a="http://schemas.openxmlformats.org/drawingml/2006/main"/>
           <a:p xmlns:a="http://schemas.openxmlformats.org/drawingml/2006/main">
             <a:pPr algn="l">
+              <a:buNone/>
               <a:defRPr sz="1275" b="0">
                 <a:solidFill>
                   <a:srgbClr val="5E6572"/>
@@ -8703,6 +8736,7 @@
           </a:p>
           <a:p xmlns:a="http://schemas.openxmlformats.org/drawingml/2006/main">
             <a:pPr algn="l">
+              <a:buNone/>
               <a:defRPr sz="1275" b="0">
                 <a:solidFill>
                   <a:srgbClr val="5E6572"/>
@@ -8850,6 +8884,7 @@
           <a:lstStyle xmlns:a="http://schemas.openxmlformats.org/drawingml/2006/main"/>
           <a:p xmlns:a="http://schemas.openxmlformats.org/drawingml/2006/main">
             <a:pPr algn="l">
+              <a:buNone/>
               <a:defRPr sz="1350" b="1">
                 <a:solidFill>
                   <a:srgbClr val="3D8DFF"/>
@@ -8902,6 +8937,7 @@
           <a:lstStyle xmlns:a="http://schemas.openxmlformats.org/drawingml/2006/main"/>
           <a:p xmlns:a="http://schemas.openxmlformats.org/drawingml/2006/main">
             <a:pPr algn="l">
+              <a:buNone/>
               <a:defRPr sz="1725" b="1">
                 <a:solidFill>
                   <a:srgbClr val="111318"/>
@@ -8954,6 +8990,7 @@
           <a:lstStyle xmlns:a="http://schemas.openxmlformats.org/drawingml/2006/main"/>
           <a:p xmlns:a="http://schemas.openxmlformats.org/drawingml/2006/main">
             <a:pPr algn="l">
+              <a:buNone/>
               <a:defRPr sz="1275" b="0">
                 <a:solidFill>
                   <a:srgbClr val="5E6572"/>
@@ -8971,6 +9008,7 @@
           </a:p>
           <a:p xmlns:a="http://schemas.openxmlformats.org/drawingml/2006/main">
             <a:pPr algn="l">
+              <a:buNone/>
               <a:defRPr sz="1275" b="0">
                 <a:solidFill>
                   <a:srgbClr val="5E6572"/>
@@ -9118,6 +9156,7 @@
           <a:lstStyle xmlns:a="http://schemas.openxmlformats.org/drawingml/2006/main"/>
           <a:p xmlns:a="http://schemas.openxmlformats.org/drawingml/2006/main">
             <a:pPr algn="l">
+              <a:buNone/>
               <a:defRPr sz="1350" b="1">
                 <a:solidFill>
                   <a:srgbClr val="3D8DFF"/>
@@ -9170,6 +9209,7 @@
           <a:lstStyle xmlns:a="http://schemas.openxmlformats.org/drawingml/2006/main"/>
           <a:p xmlns:a="http://schemas.openxmlformats.org/drawingml/2006/main">
             <a:pPr algn="l">
+              <a:buNone/>
               <a:defRPr sz="1725" b="1">
                 <a:solidFill>
                   <a:srgbClr val="111318"/>
@@ -9222,6 +9262,7 @@
           <a:lstStyle xmlns:a="http://schemas.openxmlformats.org/drawingml/2006/main"/>
           <a:p xmlns:a="http://schemas.openxmlformats.org/drawingml/2006/main">
             <a:pPr algn="l">
+              <a:buNone/>
               <a:defRPr sz="1275" b="0">
                 <a:solidFill>
                   <a:srgbClr val="5E6572"/>
@@ -9239,6 +9280,7 @@
           </a:p>
           <a:p xmlns:a="http://schemas.openxmlformats.org/drawingml/2006/main">
             <a:pPr algn="l">
+              <a:buNone/>
               <a:defRPr sz="1275" b="0">
                 <a:solidFill>
                   <a:srgbClr val="5E6572"/>
@@ -9386,6 +9428,7 @@
           <a:lstStyle xmlns:a="http://schemas.openxmlformats.org/drawingml/2006/main"/>
           <a:p xmlns:a="http://schemas.openxmlformats.org/drawingml/2006/main">
             <a:pPr algn="l">
+              <a:buNone/>
               <a:defRPr sz="1350" b="1">
                 <a:solidFill>
                   <a:srgbClr val="3D8DFF"/>
@@ -9438,6 +9481,7 @@
           <a:lstStyle xmlns:a="http://schemas.openxmlformats.org/drawingml/2006/main"/>
           <a:p xmlns:a="http://schemas.openxmlformats.org/drawingml/2006/main">
             <a:pPr algn="l">
+              <a:buNone/>
               <a:defRPr sz="1725" b="1">
                 <a:solidFill>
                   <a:srgbClr val="111318"/>
@@ -9490,6 +9534,7 @@
           <a:lstStyle xmlns:a="http://schemas.openxmlformats.org/drawingml/2006/main"/>
           <a:p xmlns:a="http://schemas.openxmlformats.org/drawingml/2006/main">
             <a:pPr algn="l">
+              <a:buNone/>
               <a:defRPr sz="1275" b="0">
                 <a:solidFill>
                   <a:srgbClr val="5E6572"/>
@@ -9507,6 +9552,7 @@
           </a:p>
           <a:p xmlns:a="http://schemas.openxmlformats.org/drawingml/2006/main">
             <a:pPr algn="l">
+              <a:buNone/>
               <a:defRPr sz="1275" b="0">
                 <a:solidFill>
                   <a:srgbClr val="5E6572"/>
@@ -9625,6 +9671,7 @@
           <a:lstStyle xmlns:a="http://schemas.openxmlformats.org/drawingml/2006/main"/>
           <a:p xmlns:a="http://schemas.openxmlformats.org/drawingml/2006/main">
             <a:pPr algn="l">
+              <a:buNone/>
               <a:defRPr sz="1575" b="1">
                 <a:solidFill>
                   <a:srgbClr val="111318"/>
@@ -9677,6 +9724,7 @@
           <a:lstStyle xmlns:a="http://schemas.openxmlformats.org/drawingml/2006/main"/>
           <a:p xmlns:a="http://schemas.openxmlformats.org/drawingml/2006/main">
             <a:pPr algn="l">
+              <a:buNone/>
               <a:defRPr sz="1275" b="0">
                 <a:solidFill>
                   <a:srgbClr val="5E6572"/>
@@ -9795,6 +9843,7 @@
           <a:lstStyle xmlns:a="http://schemas.openxmlformats.org/drawingml/2006/main"/>
           <a:p xmlns:a="http://schemas.openxmlformats.org/drawingml/2006/main">
             <a:pPr algn="l">
+              <a:buNone/>
               <a:defRPr sz="1575" b="1">
                 <a:solidFill>
                   <a:srgbClr val="111318"/>
@@ -9847,6 +9896,7 @@
           <a:lstStyle xmlns:a="http://schemas.openxmlformats.org/drawingml/2006/main"/>
           <a:p xmlns:a="http://schemas.openxmlformats.org/drawingml/2006/main">
             <a:pPr algn="l">
+              <a:buNone/>
               <a:defRPr sz="1275" b="0">
                 <a:solidFill>
                   <a:srgbClr val="5E6572"/>
@@ -9928,6 +9978,7 @@
           <a:lstStyle xmlns:a="http://schemas.openxmlformats.org/drawingml/2006/main"/>
           <a:p xmlns:a="http://schemas.openxmlformats.org/drawingml/2006/main">
             <a:pPr algn="l">
+              <a:buNone/>
               <a:defRPr sz="975" b="1">
                 <a:solidFill>
                   <a:srgbClr val="3D8DFF"/>
@@ -9980,6 +10031,7 @@
           <a:lstStyle xmlns:a="http://schemas.openxmlformats.org/drawingml/2006/main"/>
           <a:p xmlns:a="http://schemas.openxmlformats.org/drawingml/2006/main">
             <a:pPr algn="l">
+              <a:buNone/>
               <a:defRPr sz="3000" b="1">
                 <a:solidFill>
                   <a:srgbClr val="111318"/>
@@ -10063,6 +10115,7 @@
           <a:lstStyle xmlns:a="http://schemas.openxmlformats.org/drawingml/2006/main"/>
           <a:p xmlns:a="http://schemas.openxmlformats.org/drawingml/2006/main">
             <a:pPr algn="r">
+              <a:buNone/>
               <a:defRPr sz="975" b="0">
                 <a:solidFill>
                   <a:srgbClr val="8F96A3"/>
@@ -10115,6 +10168,7 @@
           <a:lstStyle xmlns:a="http://schemas.openxmlformats.org/drawingml/2006/main"/>
           <a:p xmlns:a="http://schemas.openxmlformats.org/drawingml/2006/main">
             <a:pPr algn="l">
+              <a:buNone/>
               <a:defRPr sz="1800" b="1">
                 <a:solidFill>
                   <a:srgbClr val="111318"/>
@@ -10200,6 +10254,7 @@
           <a:lstStyle xmlns:a="http://schemas.openxmlformats.org/drawingml/2006/main"/>
           <a:p xmlns:a="http://schemas.openxmlformats.org/drawingml/2006/main">
             <a:pPr algn="l">
+              <a:buNone/>
               <a:defRPr sz="1425" b="1">
                 <a:solidFill>
                   <a:srgbClr val="111318"/>
@@ -10252,6 +10307,7 @@
           <a:lstStyle xmlns:a="http://schemas.openxmlformats.org/drawingml/2006/main"/>
           <a:p xmlns:a="http://schemas.openxmlformats.org/drawingml/2006/main">
             <a:pPr algn="l">
+              <a:buNone/>
               <a:defRPr sz="1275" b="0">
                 <a:solidFill>
                   <a:srgbClr val="5E6572"/>
@@ -10337,6 +10393,7 @@
           <a:lstStyle xmlns:a="http://schemas.openxmlformats.org/drawingml/2006/main"/>
           <a:p xmlns:a="http://schemas.openxmlformats.org/drawingml/2006/main">
             <a:pPr algn="l">
+              <a:buNone/>
               <a:defRPr sz="1425" b="1">
                 <a:solidFill>
                   <a:srgbClr val="111318"/>
@@ -10389,6 +10446,7 @@
           <a:lstStyle xmlns:a="http://schemas.openxmlformats.org/drawingml/2006/main"/>
           <a:p xmlns:a="http://schemas.openxmlformats.org/drawingml/2006/main">
             <a:pPr algn="l">
+              <a:buNone/>
               <a:defRPr sz="1275" b="0">
                 <a:solidFill>
                   <a:srgbClr val="5E6572"/>
@@ -10474,6 +10532,7 @@
           <a:lstStyle xmlns:a="http://schemas.openxmlformats.org/drawingml/2006/main"/>
           <a:p xmlns:a="http://schemas.openxmlformats.org/drawingml/2006/main">
             <a:pPr algn="l">
+              <a:buNone/>
               <a:defRPr sz="1425" b="1">
                 <a:solidFill>
                   <a:srgbClr val="111318"/>
@@ -10526,6 +10585,7 @@
           <a:lstStyle xmlns:a="http://schemas.openxmlformats.org/drawingml/2006/main"/>
           <a:p xmlns:a="http://schemas.openxmlformats.org/drawingml/2006/main">
             <a:pPr algn="l">
+              <a:buNone/>
               <a:defRPr sz="1275" b="0">
                 <a:solidFill>
                   <a:srgbClr val="5E6572"/>
@@ -10611,6 +10671,7 @@
           <a:lstStyle xmlns:a="http://schemas.openxmlformats.org/drawingml/2006/main"/>
           <a:p xmlns:a="http://schemas.openxmlformats.org/drawingml/2006/main">
             <a:pPr algn="l">
+              <a:buNone/>
               <a:defRPr sz="1425" b="1">
                 <a:solidFill>
                   <a:srgbClr val="6DCBF4"/>
@@ -10663,6 +10724,7 @@
           <a:lstStyle xmlns:a="http://schemas.openxmlformats.org/drawingml/2006/main"/>
           <a:p xmlns:a="http://schemas.openxmlformats.org/drawingml/2006/main">
             <a:pPr algn="l">
+              <a:buNone/>
               <a:defRPr sz="1275" b="0">
                 <a:solidFill>
                   <a:srgbClr val="FFFFFF"/>
@@ -10715,6 +10777,7 @@
           <a:lstStyle xmlns:a="http://schemas.openxmlformats.org/drawingml/2006/main"/>
           <a:p xmlns:a="http://schemas.openxmlformats.org/drawingml/2006/main">
             <a:pPr algn="l">
+              <a:buNone/>
               <a:defRPr sz="1800" b="1">
                 <a:solidFill>
                   <a:srgbClr val="111318"/>
@@ -10798,6 +10861,7 @@
           <a:lstStyle xmlns:a="http://schemas.openxmlformats.org/drawingml/2006/main"/>
           <a:p xmlns:a="http://schemas.openxmlformats.org/drawingml/2006/main">
             <a:pPr algn="l">
+              <a:buNone/>
               <a:defRPr sz="1275" b="1">
                 <a:solidFill>
                   <a:srgbClr val="3D8DFF"/>
@@ -10850,6 +10914,7 @@
           <a:lstStyle xmlns:a="http://schemas.openxmlformats.org/drawingml/2006/main"/>
           <a:p xmlns:a="http://schemas.openxmlformats.org/drawingml/2006/main">
             <a:pPr algn="l">
+              <a:buNone/>
               <a:defRPr sz="1350" b="1">
                 <a:solidFill>
                   <a:srgbClr val="111318"/>
@@ -10964,6 +11029,7 @@
           <a:lstStyle xmlns:a="http://schemas.openxmlformats.org/drawingml/2006/main"/>
           <a:p xmlns:a="http://schemas.openxmlformats.org/drawingml/2006/main">
             <a:pPr algn="l">
+              <a:buNone/>
               <a:defRPr sz="1275" b="1">
                 <a:solidFill>
                   <a:srgbClr val="3D8DFF"/>
@@ -11016,6 +11082,7 @@
           <a:lstStyle xmlns:a="http://schemas.openxmlformats.org/drawingml/2006/main"/>
           <a:p xmlns:a="http://schemas.openxmlformats.org/drawingml/2006/main">
             <a:pPr algn="l">
+              <a:buNone/>
               <a:defRPr sz="1350" b="1">
                 <a:solidFill>
                   <a:srgbClr val="111318"/>
@@ -11130,6 +11197,7 @@
           <a:lstStyle xmlns:a="http://schemas.openxmlformats.org/drawingml/2006/main"/>
           <a:p xmlns:a="http://schemas.openxmlformats.org/drawingml/2006/main">
             <a:pPr algn="l">
+              <a:buNone/>
               <a:defRPr sz="1275" b="1">
                 <a:solidFill>
                   <a:srgbClr val="3D8DFF"/>
@@ -11182,6 +11250,7 @@
           <a:lstStyle xmlns:a="http://schemas.openxmlformats.org/drawingml/2006/main"/>
           <a:p xmlns:a="http://schemas.openxmlformats.org/drawingml/2006/main">
             <a:pPr algn="l">
+              <a:buNone/>
               <a:defRPr sz="1350" b="1">
                 <a:solidFill>
                   <a:srgbClr val="111318"/>
@@ -11296,6 +11365,7 @@
           <a:lstStyle xmlns:a="http://schemas.openxmlformats.org/drawingml/2006/main"/>
           <a:p xmlns:a="http://schemas.openxmlformats.org/drawingml/2006/main">
             <a:pPr algn="l">
+              <a:buNone/>
               <a:defRPr sz="1275" b="1">
                 <a:solidFill>
                   <a:srgbClr val="3D8DFF"/>
@@ -11348,6 +11418,7 @@
           <a:lstStyle xmlns:a="http://schemas.openxmlformats.org/drawingml/2006/main"/>
           <a:p xmlns:a="http://schemas.openxmlformats.org/drawingml/2006/main">
             <a:pPr algn="l">
+              <a:buNone/>
               <a:defRPr sz="1350" b="1">
                 <a:solidFill>
                   <a:srgbClr val="111318"/>
@@ -11462,6 +11533,7 @@
           <a:lstStyle xmlns:a="http://schemas.openxmlformats.org/drawingml/2006/main"/>
           <a:p xmlns:a="http://schemas.openxmlformats.org/drawingml/2006/main">
             <a:pPr algn="l">
+              <a:buNone/>
               <a:defRPr sz="1275" b="1">
                 <a:solidFill>
                   <a:srgbClr val="3D8DFF"/>
@@ -11514,6 +11586,7 @@
           <a:lstStyle xmlns:a="http://schemas.openxmlformats.org/drawingml/2006/main"/>
           <a:p xmlns:a="http://schemas.openxmlformats.org/drawingml/2006/main">
             <a:pPr algn="l">
+              <a:buNone/>
               <a:defRPr sz="1350" b="1">
                 <a:solidFill>
                   <a:srgbClr val="111318"/>
@@ -11599,6 +11672,7 @@
           <a:lstStyle xmlns:a="http://schemas.openxmlformats.org/drawingml/2006/main"/>
           <a:p xmlns:a="http://schemas.openxmlformats.org/drawingml/2006/main">
             <a:pPr algn="ctr">
+              <a:buNone/>
               <a:defRPr sz="1200" b="1">
                 <a:solidFill>
                   <a:srgbClr val="2D9D78"/>
@@ -11680,6 +11754,7 @@
           <a:lstStyle xmlns:a="http://schemas.openxmlformats.org/drawingml/2006/main"/>
           <a:p xmlns:a="http://schemas.openxmlformats.org/drawingml/2006/main">
             <a:pPr algn="l">
+              <a:buNone/>
               <a:defRPr sz="975" b="1">
                 <a:solidFill>
                   <a:srgbClr val="3D8DFF"/>
@@ -11732,6 +11807,7 @@
           <a:lstStyle xmlns:a="http://schemas.openxmlformats.org/drawingml/2006/main"/>
           <a:p xmlns:a="http://schemas.openxmlformats.org/drawingml/2006/main">
             <a:pPr algn="l">
+              <a:buNone/>
               <a:defRPr sz="3000" b="1">
                 <a:solidFill>
                   <a:srgbClr val="111318"/>
@@ -11815,6 +11891,7 @@
           <a:lstStyle xmlns:a="http://schemas.openxmlformats.org/drawingml/2006/main"/>
           <a:p xmlns:a="http://schemas.openxmlformats.org/drawingml/2006/main">
             <a:pPr algn="r">
+              <a:buNone/>
               <a:defRPr sz="975" b="0">
                 <a:solidFill>
                   <a:srgbClr val="8F96A3"/>
@@ -11900,6 +11977,7 @@
           <a:lstStyle xmlns:a="http://schemas.openxmlformats.org/drawingml/2006/main"/>
           <a:p xmlns:a="http://schemas.openxmlformats.org/drawingml/2006/main">
             <a:pPr algn="l">
+              <a:buNone/>
               <a:defRPr sz="1425" b="1">
                 <a:solidFill>
                   <a:srgbClr val="6DCBF4"/>
@@ -11952,6 +12030,7 @@
           <a:lstStyle xmlns:a="http://schemas.openxmlformats.org/drawingml/2006/main"/>
           <a:p xmlns:a="http://schemas.openxmlformats.org/drawingml/2006/main">
             <a:pPr algn="l">
+              <a:buNone/>
               <a:defRPr sz="1425" b="1">
                 <a:solidFill>
                   <a:srgbClr val="FFFFFF"/>
@@ -12004,6 +12083,7 @@
           <a:lstStyle xmlns:a="http://schemas.openxmlformats.org/drawingml/2006/main"/>
           <a:p xmlns:a="http://schemas.openxmlformats.org/drawingml/2006/main">
             <a:pPr algn="l">
+              <a:buNone/>
               <a:defRPr sz="1425" b="1">
                 <a:solidFill>
                   <a:srgbClr val="FFFFFF"/>
@@ -12056,6 +12136,7 @@
           <a:lstStyle xmlns:a="http://schemas.openxmlformats.org/drawingml/2006/main"/>
           <a:p xmlns:a="http://schemas.openxmlformats.org/drawingml/2006/main">
             <a:pPr algn="r">
+              <a:buNone/>
               <a:defRPr sz="1050" b="1">
                 <a:solidFill>
                   <a:srgbClr val="6DCBF4"/>
@@ -12141,6 +12222,7 @@
           <a:lstStyle xmlns:a="http://schemas.openxmlformats.org/drawingml/2006/main"/>
           <a:p xmlns:a="http://schemas.openxmlformats.org/drawingml/2006/main">
             <a:pPr algn="l">
+              <a:buNone/>
               <a:defRPr sz="1575" b="1">
                 <a:solidFill>
                   <a:srgbClr val="111318"/>
@@ -12193,6 +12275,7 @@
           <a:lstStyle xmlns:a="http://schemas.openxmlformats.org/drawingml/2006/main"/>
           <a:p xmlns:a="http://schemas.openxmlformats.org/drawingml/2006/main">
             <a:pPr algn="l">
+              <a:buNone/>
               <a:defRPr sz="1350" b="1">
                 <a:solidFill>
                   <a:srgbClr val="3D8DFF"/>
@@ -12245,6 +12328,7 @@
           <a:lstStyle xmlns:a="http://schemas.openxmlformats.org/drawingml/2006/main"/>
           <a:p xmlns:a="http://schemas.openxmlformats.org/drawingml/2006/main">
             <a:pPr algn="l">
+              <a:buNone/>
               <a:defRPr sz="1200" b="0">
                 <a:solidFill>
                   <a:srgbClr val="5E6572"/>
@@ -12330,6 +12414,7 @@
           <a:lstStyle xmlns:a="http://schemas.openxmlformats.org/drawingml/2006/main"/>
           <a:p xmlns:a="http://schemas.openxmlformats.org/drawingml/2006/main">
             <a:pPr algn="l">
+              <a:buNone/>
               <a:defRPr sz="1575" b="1">
                 <a:solidFill>
                   <a:srgbClr val="111318"/>
@@ -12382,6 +12467,7 @@
           <a:lstStyle xmlns:a="http://schemas.openxmlformats.org/drawingml/2006/main"/>
           <a:p xmlns:a="http://schemas.openxmlformats.org/drawingml/2006/main">
             <a:pPr algn="l">
+              <a:buNone/>
               <a:defRPr sz="1350" b="1">
                 <a:solidFill>
                   <a:srgbClr val="3D8DFF"/>
@@ -12434,6 +12520,7 @@
           <a:lstStyle xmlns:a="http://schemas.openxmlformats.org/drawingml/2006/main"/>
           <a:p xmlns:a="http://schemas.openxmlformats.org/drawingml/2006/main">
             <a:pPr algn="l">
+              <a:buNone/>
               <a:defRPr sz="1200" b="0">
                 <a:solidFill>
                   <a:srgbClr val="5E6572"/>
@@ -12519,6 +12606,7 @@
           <a:lstStyle xmlns:a="http://schemas.openxmlformats.org/drawingml/2006/main"/>
           <a:p xmlns:a="http://schemas.openxmlformats.org/drawingml/2006/main">
             <a:pPr algn="l">
+              <a:buNone/>
               <a:defRPr sz="1575" b="1">
                 <a:solidFill>
                   <a:srgbClr val="111318"/>
@@ -12571,6 +12659,7 @@
           <a:lstStyle xmlns:a="http://schemas.openxmlformats.org/drawingml/2006/main"/>
           <a:p xmlns:a="http://schemas.openxmlformats.org/drawingml/2006/main">
             <a:pPr algn="l">
+              <a:buNone/>
               <a:defRPr sz="1350" b="1">
                 <a:solidFill>
                   <a:srgbClr val="3D8DFF"/>
@@ -12623,6 +12712,7 @@
           <a:lstStyle xmlns:a="http://schemas.openxmlformats.org/drawingml/2006/main"/>
           <a:p xmlns:a="http://schemas.openxmlformats.org/drawingml/2006/main">
             <a:pPr algn="l">
+              <a:buNone/>
               <a:defRPr sz="1200" b="0">
                 <a:solidFill>
                   <a:srgbClr val="5E6572"/>
@@ -12708,6 +12798,7 @@
           <a:lstStyle xmlns:a="http://schemas.openxmlformats.org/drawingml/2006/main"/>
           <a:p xmlns:a="http://schemas.openxmlformats.org/drawingml/2006/main">
             <a:pPr algn="l">
+              <a:buNone/>
               <a:defRPr sz="1575" b="1">
                 <a:solidFill>
                   <a:srgbClr val="111318"/>
@@ -12760,6 +12851,7 @@
           <a:lstStyle xmlns:a="http://schemas.openxmlformats.org/drawingml/2006/main"/>
           <a:p xmlns:a="http://schemas.openxmlformats.org/drawingml/2006/main">
             <a:pPr algn="l">
+              <a:buNone/>
               <a:defRPr sz="1350" b="1">
                 <a:solidFill>
                   <a:srgbClr val="3D8DFF"/>
@@ -12812,6 +12904,7 @@
           <a:lstStyle xmlns:a="http://schemas.openxmlformats.org/drawingml/2006/main"/>
           <a:p xmlns:a="http://schemas.openxmlformats.org/drawingml/2006/main">
             <a:pPr algn="l">
+              <a:buNone/>
               <a:defRPr sz="1200" b="0">
                 <a:solidFill>
                   <a:srgbClr val="5E6572"/>
@@ -12930,6 +13023,7 @@
           <a:lstStyle xmlns:a="http://schemas.openxmlformats.org/drawingml/2006/main"/>
           <a:p xmlns:a="http://schemas.openxmlformats.org/drawingml/2006/main">
             <a:pPr algn="l">
+              <a:buNone/>
               <a:defRPr sz="1425" b="1">
                 <a:solidFill>
                   <a:srgbClr val="111318"/>
@@ -12982,6 +13076,7 @@
           <a:lstStyle xmlns:a="http://schemas.openxmlformats.org/drawingml/2006/main"/>
           <a:p xmlns:a="http://schemas.openxmlformats.org/drawingml/2006/main">
             <a:pPr algn="l">
+              <a:buNone/>
               <a:defRPr sz="1275" b="1">
                 <a:solidFill>
                   <a:srgbClr val="0E3A66"/>
@@ -13063,6 +13158,7 @@
           <a:lstStyle xmlns:a="http://schemas.openxmlformats.org/drawingml/2006/main"/>
           <a:p xmlns:a="http://schemas.openxmlformats.org/drawingml/2006/main">
             <a:pPr algn="l">
+              <a:buNone/>
               <a:defRPr sz="975" b="1">
                 <a:solidFill>
                   <a:srgbClr val="3D8DFF"/>
@@ -13115,6 +13211,7 @@
           <a:lstStyle xmlns:a="http://schemas.openxmlformats.org/drawingml/2006/main"/>
           <a:p xmlns:a="http://schemas.openxmlformats.org/drawingml/2006/main">
             <a:pPr algn="l">
+              <a:buNone/>
               <a:defRPr sz="3000" b="1">
                 <a:solidFill>
                   <a:srgbClr val="111318"/>
@@ -13198,6 +13295,7 @@
           <a:lstStyle xmlns:a="http://schemas.openxmlformats.org/drawingml/2006/main"/>
           <a:p xmlns:a="http://schemas.openxmlformats.org/drawingml/2006/main">
             <a:pPr algn="r">
+              <a:buNone/>
               <a:defRPr sz="975" b="0">
                 <a:solidFill>
                   <a:srgbClr val="8F96A3"/>
@@ -13250,6 +13348,7 @@
           <a:lstStyle xmlns:a="http://schemas.openxmlformats.org/drawingml/2006/main"/>
           <a:p xmlns:a="http://schemas.openxmlformats.org/drawingml/2006/main">
             <a:pPr algn="l">
+              <a:buNone/>
               <a:defRPr sz="1500" b="0">
                 <a:solidFill>
                   <a:srgbClr val="5E6572"/>
@@ -13335,6 +13434,7 @@
           <a:lstStyle xmlns:a="http://schemas.openxmlformats.org/drawingml/2006/main"/>
           <a:p xmlns:a="http://schemas.openxmlformats.org/drawingml/2006/main">
             <a:pPr algn="ctr">
+              <a:buNone/>
               <a:defRPr sz="3375" b="1">
                 <a:solidFill>
                   <a:srgbClr val="111318"/>
@@ -13387,6 +13487,7 @@
           <a:lstStyle xmlns:a="http://schemas.openxmlformats.org/drawingml/2006/main"/>
           <a:p xmlns:a="http://schemas.openxmlformats.org/drawingml/2006/main">
             <a:pPr algn="ctr">
+              <a:buNone/>
               <a:defRPr sz="1650" b="1">
                 <a:solidFill>
                   <a:srgbClr val="111318"/>
@@ -13439,6 +13540,7 @@
           <a:lstStyle xmlns:a="http://schemas.openxmlformats.org/drawingml/2006/main"/>
           <a:p xmlns:a="http://schemas.openxmlformats.org/drawingml/2006/main">
             <a:pPr algn="ctr">
+              <a:buNone/>
               <a:defRPr sz="1200" b="0">
                 <a:solidFill>
                   <a:srgbClr val="5E6572"/>
@@ -13524,6 +13626,7 @@
           <a:lstStyle xmlns:a="http://schemas.openxmlformats.org/drawingml/2006/main"/>
           <a:p xmlns:a="http://schemas.openxmlformats.org/drawingml/2006/main">
             <a:pPr algn="ctr">
+              <a:buNone/>
               <a:defRPr sz="3375" b="1">
                 <a:solidFill>
                   <a:srgbClr val="3D8DFF"/>
@@ -13576,6 +13679,7 @@
           <a:lstStyle xmlns:a="http://schemas.openxmlformats.org/drawingml/2006/main"/>
           <a:p xmlns:a="http://schemas.openxmlformats.org/drawingml/2006/main">
             <a:pPr algn="ctr">
+              <a:buNone/>
               <a:defRPr sz="1650" b="1">
                 <a:solidFill>
                   <a:srgbClr val="111318"/>
@@ -13628,6 +13732,7 @@
           <a:lstStyle xmlns:a="http://schemas.openxmlformats.org/drawingml/2006/main"/>
           <a:p xmlns:a="http://schemas.openxmlformats.org/drawingml/2006/main">
             <a:pPr algn="ctr">
+              <a:buNone/>
               <a:defRPr sz="1200" b="0">
                 <a:solidFill>
                   <a:srgbClr val="5E6572"/>
@@ -13713,6 +13818,7 @@
           <a:lstStyle xmlns:a="http://schemas.openxmlformats.org/drawingml/2006/main"/>
           <a:p xmlns:a="http://schemas.openxmlformats.org/drawingml/2006/main">
             <a:pPr algn="ctr">
+              <a:buNone/>
               <a:defRPr sz="3375" b="1">
                 <a:solidFill>
                   <a:srgbClr val="E3545B"/>
@@ -13765,6 +13871,7 @@
           <a:lstStyle xmlns:a="http://schemas.openxmlformats.org/drawingml/2006/main"/>
           <a:p xmlns:a="http://schemas.openxmlformats.org/drawingml/2006/main">
             <a:pPr algn="ctr">
+              <a:buNone/>
               <a:defRPr sz="1650" b="1">
                 <a:solidFill>
                   <a:srgbClr val="111318"/>
@@ -13817,6 +13924,7 @@
           <a:lstStyle xmlns:a="http://schemas.openxmlformats.org/drawingml/2006/main"/>
           <a:p xmlns:a="http://schemas.openxmlformats.org/drawingml/2006/main">
             <a:pPr algn="ctr">
+              <a:buNone/>
               <a:defRPr sz="1200" b="0">
                 <a:solidFill>
                   <a:srgbClr val="5E6572"/>
@@ -13902,6 +14010,7 @@
           <a:lstStyle xmlns:a="http://schemas.openxmlformats.org/drawingml/2006/main"/>
           <a:p xmlns:a="http://schemas.openxmlformats.org/drawingml/2006/main">
             <a:pPr algn="ctr">
+              <a:buNone/>
               <a:defRPr sz="3375" b="1">
                 <a:solidFill>
                   <a:srgbClr val="2D9D78"/>
@@ -13954,6 +14063,7 @@
           <a:lstStyle xmlns:a="http://schemas.openxmlformats.org/drawingml/2006/main"/>
           <a:p xmlns:a="http://schemas.openxmlformats.org/drawingml/2006/main">
             <a:pPr algn="ctr">
+              <a:buNone/>
               <a:defRPr sz="1650" b="1">
                 <a:solidFill>
                   <a:srgbClr val="111318"/>
@@ -14006,6 +14116,7 @@
           <a:lstStyle xmlns:a="http://schemas.openxmlformats.org/drawingml/2006/main"/>
           <a:p xmlns:a="http://schemas.openxmlformats.org/drawingml/2006/main">
             <a:pPr algn="ctr">
+              <a:buNone/>
               <a:defRPr sz="1200" b="0">
                 <a:solidFill>
                   <a:srgbClr val="5E6572"/>
@@ -14091,6 +14202,7 @@
           <a:lstStyle xmlns:a="http://schemas.openxmlformats.org/drawingml/2006/main"/>
           <a:p xmlns:a="http://schemas.openxmlformats.org/drawingml/2006/main">
             <a:pPr algn="l">
+              <a:buNone/>
               <a:defRPr sz="1350" b="1">
                 <a:solidFill>
                   <a:srgbClr val="6DCBF4"/>
@@ -14143,6 +14255,7 @@
           <a:lstStyle xmlns:a="http://schemas.openxmlformats.org/drawingml/2006/main"/>
           <a:p xmlns:a="http://schemas.openxmlformats.org/drawingml/2006/main">
             <a:pPr algn="l">
+              <a:buNone/>
               <a:defRPr sz="1500" b="1">
                 <a:solidFill>
                   <a:srgbClr val="FFFFFF"/>
@@ -14224,6 +14337,7 @@
           <a:lstStyle xmlns:a="http://schemas.openxmlformats.org/drawingml/2006/main"/>
           <a:p xmlns:a="http://schemas.openxmlformats.org/drawingml/2006/main">
             <a:pPr algn="l">
+              <a:buNone/>
               <a:defRPr sz="975" b="1">
                 <a:solidFill>
                   <a:srgbClr val="3D8DFF"/>
@@ -14276,6 +14390,7 @@
           <a:lstStyle xmlns:a="http://schemas.openxmlformats.org/drawingml/2006/main"/>
           <a:p xmlns:a="http://schemas.openxmlformats.org/drawingml/2006/main">
             <a:pPr algn="l">
+              <a:buNone/>
               <a:defRPr sz="3000" b="1">
                 <a:solidFill>
                   <a:srgbClr val="111318"/>
@@ -14359,6 +14474,7 @@
           <a:lstStyle xmlns:a="http://schemas.openxmlformats.org/drawingml/2006/main"/>
           <a:p xmlns:a="http://schemas.openxmlformats.org/drawingml/2006/main">
             <a:pPr algn="r">
+              <a:buNone/>
               <a:defRPr sz="975" b="0">
                 <a:solidFill>
                   <a:srgbClr val="8F96A3"/>
@@ -14411,6 +14527,7 @@
           <a:lstStyle xmlns:a="http://schemas.openxmlformats.org/drawingml/2006/main"/>
           <a:p xmlns:a="http://schemas.openxmlformats.org/drawingml/2006/main">
             <a:pPr algn="l">
+              <a:buNone/>
               <a:defRPr sz="1800" b="1">
                 <a:solidFill>
                   <a:srgbClr val="111318"/>
@@ -14569,6 +14686,7 @@
           <a:lstStyle xmlns:a="http://schemas.openxmlformats.org/drawingml/2006/main"/>
           <a:p xmlns:a="http://schemas.openxmlformats.org/drawingml/2006/main">
             <a:pPr algn="l">
+              <a:buNone/>
               <a:defRPr sz="1125" b="1">
                 <a:solidFill>
                   <a:srgbClr val="FFFFFF"/>
@@ -14654,6 +14772,7 @@
           <a:lstStyle xmlns:a="http://schemas.openxmlformats.org/drawingml/2006/main"/>
           <a:p xmlns:a="http://schemas.openxmlformats.org/drawingml/2006/main">
             <a:pPr algn="l">
+              <a:buNone/>
               <a:defRPr sz="1125" b="1">
                 <a:solidFill>
                   <a:srgbClr val="FFFFFF"/>
@@ -14739,6 +14858,7 @@
           <a:lstStyle xmlns:a="http://schemas.openxmlformats.org/drawingml/2006/main"/>
           <a:p xmlns:a="http://schemas.openxmlformats.org/drawingml/2006/main">
             <a:pPr algn="l">
+              <a:buNone/>
               <a:defRPr sz="1200" b="0">
                 <a:solidFill>
                   <a:srgbClr val="111318"/>
@@ -14824,6 +14944,7 @@
           <a:lstStyle xmlns:a="http://schemas.openxmlformats.org/drawingml/2006/main"/>
           <a:p xmlns:a="http://schemas.openxmlformats.org/drawingml/2006/main">
             <a:pPr algn="l">
+              <a:buNone/>
               <a:defRPr sz="1200" b="1">
                 <a:solidFill>
                   <a:srgbClr val="111318"/>
@@ -14841,6 +14962,7 @@
           </a:p>
           <a:p xmlns:a="http://schemas.openxmlformats.org/drawingml/2006/main">
             <a:pPr algn="l">
+              <a:buNone/>
               <a:defRPr sz="1200" b="1">
                 <a:solidFill>
                   <a:srgbClr val="111318"/>
@@ -14926,6 +15048,7 @@
           <a:lstStyle xmlns:a="http://schemas.openxmlformats.org/drawingml/2006/main"/>
           <a:p xmlns:a="http://schemas.openxmlformats.org/drawingml/2006/main">
             <a:pPr algn="l">
+              <a:buNone/>
               <a:defRPr sz="1200" b="0">
                 <a:solidFill>
                   <a:srgbClr val="111318"/>
@@ -14943,6 +15066,7 @@
           </a:p>
           <a:p xmlns:a="http://schemas.openxmlformats.org/drawingml/2006/main">
             <a:pPr algn="l">
+              <a:buNone/>
               <a:defRPr sz="1200" b="0">
                 <a:solidFill>
                   <a:srgbClr val="111318"/>
@@ -15028,6 +15152,7 @@
           <a:lstStyle xmlns:a="http://schemas.openxmlformats.org/drawingml/2006/main"/>
           <a:p xmlns:a="http://schemas.openxmlformats.org/drawingml/2006/main">
             <a:pPr algn="l">
+              <a:buNone/>
               <a:defRPr sz="1200" b="0">
                 <a:solidFill>
                   <a:srgbClr val="111318"/>
@@ -15113,6 +15238,7 @@
           <a:lstStyle xmlns:a="http://schemas.openxmlformats.org/drawingml/2006/main"/>
           <a:p xmlns:a="http://schemas.openxmlformats.org/drawingml/2006/main">
             <a:pPr algn="l">
+              <a:buNone/>
               <a:defRPr sz="1200" b="0">
                 <a:solidFill>
                   <a:srgbClr val="111318"/>
@@ -15130,6 +15256,7 @@
           </a:p>
           <a:p xmlns:a="http://schemas.openxmlformats.org/drawingml/2006/main">
             <a:pPr algn="l">
+              <a:buNone/>
               <a:defRPr sz="1200" b="0">
                 <a:solidFill>
                   <a:srgbClr val="111318"/>
@@ -15215,6 +15342,7 @@
           <a:lstStyle xmlns:a="http://schemas.openxmlformats.org/drawingml/2006/main"/>
           <a:p xmlns:a="http://schemas.openxmlformats.org/drawingml/2006/main">
             <a:pPr algn="l">
+              <a:buNone/>
               <a:defRPr sz="1200" b="1">
                 <a:solidFill>
                   <a:srgbClr val="111318"/>
@@ -15232,6 +15360,7 @@
           </a:p>
           <a:p xmlns:a="http://schemas.openxmlformats.org/drawingml/2006/main">
             <a:pPr algn="l">
+              <a:buNone/>
               <a:defRPr sz="1200" b="1">
                 <a:solidFill>
                   <a:srgbClr val="111318"/>
@@ -15317,6 +15446,7 @@
           <a:lstStyle xmlns:a="http://schemas.openxmlformats.org/drawingml/2006/main"/>
           <a:p xmlns:a="http://schemas.openxmlformats.org/drawingml/2006/main">
             <a:pPr algn="l">
+              <a:buNone/>
               <a:defRPr sz="1350" b="1">
                 <a:solidFill>
                   <a:srgbClr val="E3545B"/>
@@ -15369,6 +15499,7 @@
           <a:lstStyle xmlns:a="http://schemas.openxmlformats.org/drawingml/2006/main"/>
           <a:p xmlns:a="http://schemas.openxmlformats.org/drawingml/2006/main">
             <a:pPr algn="l">
+              <a:buNone/>
               <a:defRPr sz="1500" b="1">
                 <a:solidFill>
                   <a:srgbClr val="111318"/>
@@ -15421,6 +15552,7 @@
           <a:lstStyle xmlns:a="http://schemas.openxmlformats.org/drawingml/2006/main"/>
           <a:p xmlns:a="http://schemas.openxmlformats.org/drawingml/2006/main">
             <a:pPr algn="l">
+              <a:buNone/>
               <a:defRPr sz="1800" b="1">
                 <a:solidFill>
                   <a:srgbClr val="111318"/>
@@ -15473,6 +15605,7 @@
           <a:lstStyle xmlns:a="http://schemas.openxmlformats.org/drawingml/2006/main"/>
           <a:p xmlns:a="http://schemas.openxmlformats.org/drawingml/2006/main">
             <a:pPr algn="l">
+              <a:buNone/>
               <a:defRPr sz="1275" b="1">
                 <a:solidFill>
                   <a:srgbClr val="111318"/>
@@ -15591,6 +15724,7 @@
           <a:lstStyle xmlns:a="http://schemas.openxmlformats.org/drawingml/2006/main"/>
           <a:p xmlns:a="http://schemas.openxmlformats.org/drawingml/2006/main">
             <a:pPr algn="r">
+              <a:buNone/>
               <a:defRPr sz="1350" b="1">
                 <a:solidFill>
                   <a:srgbClr val="111318"/>
@@ -15643,6 +15777,7 @@
           <a:lstStyle xmlns:a="http://schemas.openxmlformats.org/drawingml/2006/main"/>
           <a:p xmlns:a="http://schemas.openxmlformats.org/drawingml/2006/main">
             <a:pPr algn="l">
+              <a:buNone/>
               <a:defRPr sz="1050" b="0">
                 <a:solidFill>
                   <a:srgbClr val="8F96A3"/>
@@ -15695,6 +15830,7 @@
           <a:lstStyle xmlns:a="http://schemas.openxmlformats.org/drawingml/2006/main"/>
           <a:p xmlns:a="http://schemas.openxmlformats.org/drawingml/2006/main">
             <a:pPr algn="l">
+              <a:buNone/>
               <a:defRPr sz="1275" b="1">
                 <a:solidFill>
                   <a:srgbClr val="111318"/>
@@ -15813,6 +15949,7 @@
           <a:lstStyle xmlns:a="http://schemas.openxmlformats.org/drawingml/2006/main"/>
           <a:p xmlns:a="http://schemas.openxmlformats.org/drawingml/2006/main">
             <a:pPr algn="r">
+              <a:buNone/>
               <a:defRPr sz="1350" b="1">
                 <a:solidFill>
                   <a:srgbClr val="111318"/>
@@ -15865,6 +16002,7 @@
           <a:lstStyle xmlns:a="http://schemas.openxmlformats.org/drawingml/2006/main"/>
           <a:p xmlns:a="http://schemas.openxmlformats.org/drawingml/2006/main">
             <a:pPr algn="l">
+              <a:buNone/>
               <a:defRPr sz="1050" b="0">
                 <a:solidFill>
                   <a:srgbClr val="8F96A3"/>
@@ -15917,6 +16055,7 @@
           <a:lstStyle xmlns:a="http://schemas.openxmlformats.org/drawingml/2006/main"/>
           <a:p xmlns:a="http://schemas.openxmlformats.org/drawingml/2006/main">
             <a:pPr algn="l">
+              <a:buNone/>
               <a:defRPr sz="1275" b="1">
                 <a:solidFill>
                   <a:srgbClr val="111318"/>
@@ -16035,6 +16174,7 @@
           <a:lstStyle xmlns:a="http://schemas.openxmlformats.org/drawingml/2006/main"/>
           <a:p xmlns:a="http://schemas.openxmlformats.org/drawingml/2006/main">
             <a:pPr algn="r">
+              <a:buNone/>
               <a:defRPr sz="1350" b="1">
                 <a:solidFill>
                   <a:srgbClr val="111318"/>
@@ -16087,6 +16227,7 @@
           <a:lstStyle xmlns:a="http://schemas.openxmlformats.org/drawingml/2006/main"/>
           <a:p xmlns:a="http://schemas.openxmlformats.org/drawingml/2006/main">
             <a:pPr algn="l">
+              <a:buNone/>
               <a:defRPr sz="1050" b="0">
                 <a:solidFill>
                   <a:srgbClr val="8F96A3"/>
@@ -16172,6 +16313,7 @@
           <a:lstStyle xmlns:a="http://schemas.openxmlformats.org/drawingml/2006/main"/>
           <a:p xmlns:a="http://schemas.openxmlformats.org/drawingml/2006/main">
             <a:pPr algn="ctr">
+              <a:buNone/>
               <a:defRPr sz="1275" b="1">
                 <a:solidFill>
                   <a:srgbClr val="111318"/>
@@ -16253,6 +16395,7 @@
           <a:lstStyle xmlns:a="http://schemas.openxmlformats.org/drawingml/2006/main"/>
           <a:p xmlns:a="http://schemas.openxmlformats.org/drawingml/2006/main">
             <a:pPr algn="l">
+              <a:buNone/>
               <a:defRPr sz="975" b="1">
                 <a:solidFill>
                   <a:srgbClr val="3D8DFF"/>
@@ -16305,6 +16448,7 @@
           <a:lstStyle xmlns:a="http://schemas.openxmlformats.org/drawingml/2006/main"/>
           <a:p xmlns:a="http://schemas.openxmlformats.org/drawingml/2006/main">
             <a:pPr algn="l">
+              <a:buNone/>
               <a:defRPr sz="3000" b="1">
                 <a:solidFill>
                   <a:srgbClr val="111318"/>
@@ -16388,6 +16532,7 @@
           <a:lstStyle xmlns:a="http://schemas.openxmlformats.org/drawingml/2006/main"/>
           <a:p xmlns:a="http://schemas.openxmlformats.org/drawingml/2006/main">
             <a:pPr algn="r">
+              <a:buNone/>
               <a:defRPr sz="975" b="0">
                 <a:solidFill>
                   <a:srgbClr val="8F96A3"/>
@@ -16473,6 +16618,7 @@
           <a:lstStyle xmlns:a="http://schemas.openxmlformats.org/drawingml/2006/main"/>
           <a:p xmlns:a="http://schemas.openxmlformats.org/drawingml/2006/main">
             <a:pPr algn="l">
+              <a:buNone/>
               <a:defRPr sz="1575" b="1">
                 <a:solidFill>
                   <a:srgbClr val="111318"/>
@@ -16525,6 +16671,7 @@
           <a:lstStyle xmlns:a="http://schemas.openxmlformats.org/drawingml/2006/main"/>
           <a:p xmlns:a="http://schemas.openxmlformats.org/drawingml/2006/main">
             <a:pPr algn="l">
+              <a:buNone/>
               <a:defRPr sz="2700" b="1">
                 <a:solidFill>
                   <a:srgbClr val="2D9D78"/>
@@ -16577,6 +16724,7 @@
           <a:lstStyle xmlns:a="http://schemas.openxmlformats.org/drawingml/2006/main"/>
           <a:p xmlns:a="http://schemas.openxmlformats.org/drawingml/2006/main">
             <a:pPr algn="l">
+              <a:buNone/>
               <a:defRPr sz="1200" b="0">
                 <a:solidFill>
                   <a:srgbClr val="5E6572"/>
@@ -16662,6 +16810,7 @@
           <a:lstStyle xmlns:a="http://schemas.openxmlformats.org/drawingml/2006/main"/>
           <a:p xmlns:a="http://schemas.openxmlformats.org/drawingml/2006/main">
             <a:pPr algn="l">
+              <a:buNone/>
               <a:defRPr sz="1575" b="1">
                 <a:solidFill>
                   <a:srgbClr val="111318"/>
@@ -16714,6 +16863,7 @@
           <a:lstStyle xmlns:a="http://schemas.openxmlformats.org/drawingml/2006/main"/>
           <a:p xmlns:a="http://schemas.openxmlformats.org/drawingml/2006/main">
             <a:pPr algn="l">
+              <a:buNone/>
               <a:defRPr sz="2700" b="1">
                 <a:solidFill>
                   <a:srgbClr val="3D8DFF"/>
@@ -16766,6 +16916,7 @@
           <a:lstStyle xmlns:a="http://schemas.openxmlformats.org/drawingml/2006/main"/>
           <a:p xmlns:a="http://schemas.openxmlformats.org/drawingml/2006/main">
             <a:pPr algn="l">
+              <a:buNone/>
               <a:defRPr sz="1200" b="0">
                 <a:solidFill>
                   <a:srgbClr val="5E6572"/>
@@ -16851,6 +17002,7 @@
           <a:lstStyle xmlns:a="http://schemas.openxmlformats.org/drawingml/2006/main"/>
           <a:p xmlns:a="http://schemas.openxmlformats.org/drawingml/2006/main">
             <a:pPr algn="l">
+              <a:buNone/>
               <a:defRPr sz="1575" b="1">
                 <a:solidFill>
                   <a:srgbClr val="111318"/>
@@ -16903,6 +17055,7 @@
           <a:lstStyle xmlns:a="http://schemas.openxmlformats.org/drawingml/2006/main"/>
           <a:p xmlns:a="http://schemas.openxmlformats.org/drawingml/2006/main">
             <a:pPr algn="l">
+              <a:buNone/>
               <a:defRPr sz="2700" b="1">
                 <a:solidFill>
                   <a:srgbClr val="E59A2F"/>
@@ -16955,6 +17108,7 @@
           <a:lstStyle xmlns:a="http://schemas.openxmlformats.org/drawingml/2006/main"/>
           <a:p xmlns:a="http://schemas.openxmlformats.org/drawingml/2006/main">
             <a:pPr algn="l">
+              <a:buNone/>
               <a:defRPr sz="1200" b="0">
                 <a:solidFill>
                   <a:srgbClr val="5E6572"/>
@@ -17007,6 +17161,7 @@
           <a:lstStyle xmlns:a="http://schemas.openxmlformats.org/drawingml/2006/main"/>
           <a:p xmlns:a="http://schemas.openxmlformats.org/drawingml/2006/main">
             <a:pPr algn="l">
+              <a:buNone/>
               <a:defRPr sz="1800" b="1">
                 <a:solidFill>
                   <a:srgbClr val="111318"/>
@@ -17092,6 +17247,7 @@
           <a:lstStyle xmlns:a="http://schemas.openxmlformats.org/drawingml/2006/main"/>
           <a:p xmlns:a="http://schemas.openxmlformats.org/drawingml/2006/main">
             <a:pPr algn="ctr">
+              <a:buNone/>
               <a:defRPr sz="1050" b="1">
                 <a:solidFill>
                   <a:srgbClr val="2D9D78"/>
@@ -17144,6 +17300,7 @@
           <a:lstStyle xmlns:a="http://schemas.openxmlformats.org/drawingml/2006/main"/>
           <a:p xmlns:a="http://schemas.openxmlformats.org/drawingml/2006/main">
             <a:pPr algn="l">
+              <a:buNone/>
               <a:defRPr sz="1275" b="1">
                 <a:solidFill>
                   <a:srgbClr val="111318"/>
@@ -17229,6 +17386,7 @@
           <a:lstStyle xmlns:a="http://schemas.openxmlformats.org/drawingml/2006/main"/>
           <a:p xmlns:a="http://schemas.openxmlformats.org/drawingml/2006/main">
             <a:pPr algn="ctr">
+              <a:buNone/>
               <a:defRPr sz="1050" b="1">
                 <a:solidFill>
                   <a:srgbClr val="111318"/>
@@ -17281,6 +17439,7 @@
           <a:lstStyle xmlns:a="http://schemas.openxmlformats.org/drawingml/2006/main"/>
           <a:p xmlns:a="http://schemas.openxmlformats.org/drawingml/2006/main">
             <a:pPr algn="l">
+              <a:buNone/>
               <a:defRPr sz="1275" b="0">
                 <a:solidFill>
                   <a:srgbClr val="111318"/>
@@ -17366,6 +17525,7 @@
           <a:lstStyle xmlns:a="http://schemas.openxmlformats.org/drawingml/2006/main"/>
           <a:p xmlns:a="http://schemas.openxmlformats.org/drawingml/2006/main">
             <a:pPr algn="ctr">
+              <a:buNone/>
               <a:defRPr sz="1050" b="1">
                 <a:solidFill>
                   <a:srgbClr val="111318"/>
@@ -17418,6 +17578,7 @@
           <a:lstStyle xmlns:a="http://schemas.openxmlformats.org/drawingml/2006/main"/>
           <a:p xmlns:a="http://schemas.openxmlformats.org/drawingml/2006/main">
             <a:pPr algn="l">
+              <a:buNone/>
               <a:defRPr sz="1275" b="0">
                 <a:solidFill>
                   <a:srgbClr val="111318"/>
@@ -17470,6 +17631,7 @@
           <a:lstStyle xmlns:a="http://schemas.openxmlformats.org/drawingml/2006/main"/>
           <a:p xmlns:a="http://schemas.openxmlformats.org/drawingml/2006/main">
             <a:pPr algn="l">
+              <a:buNone/>
               <a:defRPr sz="1125" b="1">
                 <a:solidFill>
                   <a:srgbClr val="E3545B"/>
@@ -17551,6 +17713,7 @@
           <a:lstStyle xmlns:a="http://schemas.openxmlformats.org/drawingml/2006/main"/>
           <a:p xmlns:a="http://schemas.openxmlformats.org/drawingml/2006/main">
             <a:pPr algn="l">
+              <a:buNone/>
               <a:defRPr sz="975" b="1">
                 <a:solidFill>
                   <a:srgbClr val="3D8DFF"/>
@@ -17603,6 +17766,7 @@
           <a:lstStyle xmlns:a="http://schemas.openxmlformats.org/drawingml/2006/main"/>
           <a:p xmlns:a="http://schemas.openxmlformats.org/drawingml/2006/main">
             <a:pPr algn="l">
+              <a:buNone/>
               <a:defRPr sz="3000" b="1">
                 <a:solidFill>
                   <a:srgbClr val="111318"/>
@@ -17686,6 +17850,7 @@
           <a:lstStyle xmlns:a="http://schemas.openxmlformats.org/drawingml/2006/main"/>
           <a:p xmlns:a="http://schemas.openxmlformats.org/drawingml/2006/main">
             <a:pPr algn="r">
+              <a:buNone/>
               <a:defRPr sz="975" b="0">
                 <a:solidFill>
                   <a:srgbClr val="8F96A3"/>
@@ -17738,6 +17903,7 @@
           <a:lstStyle xmlns:a="http://schemas.openxmlformats.org/drawingml/2006/main"/>
           <a:p xmlns:a="http://schemas.openxmlformats.org/drawingml/2006/main">
             <a:pPr algn="l">
+              <a:buNone/>
               <a:defRPr sz="2100" b="1">
                 <a:solidFill>
                   <a:srgbClr val="0E3A66"/>
@@ -17856,6 +18022,7 @@
           <a:lstStyle xmlns:a="http://schemas.openxmlformats.org/drawingml/2006/main"/>
           <a:p xmlns:a="http://schemas.openxmlformats.org/drawingml/2006/main">
             <a:pPr algn="l">
+              <a:buNone/>
               <a:defRPr sz="1575" b="1">
                 <a:solidFill>
                   <a:srgbClr val="111318"/>
@@ -17908,6 +18075,7 @@
           <a:lstStyle xmlns:a="http://schemas.openxmlformats.org/drawingml/2006/main"/>
           <a:p xmlns:a="http://schemas.openxmlformats.org/drawingml/2006/main">
             <a:pPr algn="l">
+              <a:buNone/>
               <a:defRPr sz="1275" b="0">
                 <a:solidFill>
                   <a:srgbClr val="5E6572"/>
@@ -18026,6 +18194,7 @@
           <a:lstStyle xmlns:a="http://schemas.openxmlformats.org/drawingml/2006/main"/>
           <a:p xmlns:a="http://schemas.openxmlformats.org/drawingml/2006/main">
             <a:pPr algn="l">
+              <a:buNone/>
               <a:defRPr sz="1575" b="1">
                 <a:solidFill>
                   <a:srgbClr val="111318"/>
@@ -18078,6 +18247,7 @@
           <a:lstStyle xmlns:a="http://schemas.openxmlformats.org/drawingml/2006/main"/>
           <a:p xmlns:a="http://schemas.openxmlformats.org/drawingml/2006/main">
             <a:pPr algn="l">
+              <a:buNone/>
               <a:defRPr sz="1275" b="0">
                 <a:solidFill>
                   <a:srgbClr val="5E6572"/>
@@ -18196,6 +18366,7 @@
           <a:lstStyle xmlns:a="http://schemas.openxmlformats.org/drawingml/2006/main"/>
           <a:p xmlns:a="http://schemas.openxmlformats.org/drawingml/2006/main">
             <a:pPr algn="l">
+              <a:buNone/>
               <a:defRPr sz="1575" b="1">
                 <a:solidFill>
                   <a:srgbClr val="111318"/>
@@ -18248,6 +18419,7 @@
           <a:lstStyle xmlns:a="http://schemas.openxmlformats.org/drawingml/2006/main"/>
           <a:p xmlns:a="http://schemas.openxmlformats.org/drawingml/2006/main">
             <a:pPr algn="l">
+              <a:buNone/>
               <a:defRPr sz="1275" b="0">
                 <a:solidFill>
                   <a:srgbClr val="5E6572"/>
@@ -18300,6 +18472,7 @@
           <a:lstStyle xmlns:a="http://schemas.openxmlformats.org/drawingml/2006/main"/>
           <a:p xmlns:a="http://schemas.openxmlformats.org/drawingml/2006/main">
             <a:pPr algn="l">
+              <a:buNone/>
               <a:defRPr sz="2550" b="1">
                 <a:solidFill>
                   <a:srgbClr val="111318"/>
@@ -18352,6 +18525,7 @@
           <a:lstStyle xmlns:a="http://schemas.openxmlformats.org/drawingml/2006/main"/>
           <a:p xmlns:a="http://schemas.openxmlformats.org/drawingml/2006/main">
             <a:pPr algn="l">
+              <a:buNone/>
               <a:defRPr sz="1200" b="0">
                 <a:solidFill>
                   <a:srgbClr val="5E6572"/>
@@ -18404,6 +18578,7 @@
           <a:lstStyle xmlns:a="http://schemas.openxmlformats.org/drawingml/2006/main"/>
           <a:p xmlns:a="http://schemas.openxmlformats.org/drawingml/2006/main">
             <a:pPr algn="l">
+              <a:buNone/>
               <a:defRPr sz="2550" b="1">
                 <a:solidFill>
                   <a:srgbClr val="111318"/>
@@ -18456,6 +18631,7 @@
           <a:lstStyle xmlns:a="http://schemas.openxmlformats.org/drawingml/2006/main"/>
           <a:p xmlns:a="http://schemas.openxmlformats.org/drawingml/2006/main">
             <a:pPr algn="l">
+              <a:buNone/>
               <a:defRPr sz="1200" b="0">
                 <a:solidFill>
                   <a:srgbClr val="5E6572"/>
@@ -18508,6 +18684,7 @@
           <a:lstStyle xmlns:a="http://schemas.openxmlformats.org/drawingml/2006/main"/>
           <a:p xmlns:a="http://schemas.openxmlformats.org/drawingml/2006/main">
             <a:pPr algn="l">
+              <a:buNone/>
               <a:defRPr sz="2550" b="1">
                 <a:solidFill>
                   <a:srgbClr val="3D8DFF"/>
@@ -18560,6 +18737,7 @@
           <a:lstStyle xmlns:a="http://schemas.openxmlformats.org/drawingml/2006/main"/>
           <a:p xmlns:a="http://schemas.openxmlformats.org/drawingml/2006/main">
             <a:pPr algn="l">
+              <a:buNone/>
               <a:defRPr sz="1200" b="0">
                 <a:solidFill>
                   <a:srgbClr val="5E6572"/>
@@ -18612,6 +18790,7 @@
           <a:lstStyle xmlns:a="http://schemas.openxmlformats.org/drawingml/2006/main"/>
           <a:p xmlns:a="http://schemas.openxmlformats.org/drawingml/2006/main">
             <a:pPr algn="l">
+              <a:buNone/>
               <a:defRPr sz="2550" b="1">
                 <a:solidFill>
                   <a:srgbClr val="111318"/>
@@ -18664,6 +18843,7 @@
           <a:lstStyle xmlns:a="http://schemas.openxmlformats.org/drawingml/2006/main"/>
           <a:p xmlns:a="http://schemas.openxmlformats.org/drawingml/2006/main">
             <a:pPr algn="l">
+              <a:buNone/>
               <a:defRPr sz="1200" b="0">
                 <a:solidFill>
                   <a:srgbClr val="5E6572"/>
@@ -18716,6 +18896,7 @@
           <a:lstStyle xmlns:a="http://schemas.openxmlformats.org/drawingml/2006/main"/>
           <a:p xmlns:a="http://schemas.openxmlformats.org/drawingml/2006/main">
             <a:pPr algn="l">
+              <a:buNone/>
               <a:defRPr sz="1200" b="0">
                 <a:solidFill>
                   <a:srgbClr val="8F96A3"/>
@@ -18797,6 +18978,7 @@
           <a:lstStyle xmlns:a="http://schemas.openxmlformats.org/drawingml/2006/main"/>
           <a:p xmlns:a="http://schemas.openxmlformats.org/drawingml/2006/main">
             <a:pPr algn="l">
+              <a:buNone/>
               <a:defRPr sz="975" b="1">
                 <a:solidFill>
                   <a:srgbClr val="3D8DFF"/>
@@ -18849,6 +19031,7 @@
           <a:lstStyle xmlns:a="http://schemas.openxmlformats.org/drawingml/2006/main"/>
           <a:p xmlns:a="http://schemas.openxmlformats.org/drawingml/2006/main">
             <a:pPr algn="l">
+              <a:buNone/>
               <a:defRPr sz="3000" b="1">
                 <a:solidFill>
                   <a:srgbClr val="111318"/>
@@ -18932,6 +19115,7 @@
           <a:lstStyle xmlns:a="http://schemas.openxmlformats.org/drawingml/2006/main"/>
           <a:p xmlns:a="http://schemas.openxmlformats.org/drawingml/2006/main">
             <a:pPr algn="r">
+              <a:buNone/>
               <a:defRPr sz="975" b="0">
                 <a:solidFill>
                   <a:srgbClr val="8F96A3"/>
@@ -18984,6 +19168,7 @@
           <a:lstStyle xmlns:a="http://schemas.openxmlformats.org/drawingml/2006/main"/>
           <a:p xmlns:a="http://schemas.openxmlformats.org/drawingml/2006/main">
             <a:pPr algn="l">
+              <a:buNone/>
               <a:defRPr sz="2025" b="1">
                 <a:solidFill>
                   <a:srgbClr val="0E3A66"/>
@@ -19069,6 +19254,7 @@
           <a:lstStyle xmlns:a="http://schemas.openxmlformats.org/drawingml/2006/main"/>
           <a:p xmlns:a="http://schemas.openxmlformats.org/drawingml/2006/main">
             <a:pPr algn="ctr">
+              <a:buNone/>
               <a:defRPr sz="1500" b="1">
                 <a:solidFill>
                   <a:srgbClr val="FFFFFF"/>
@@ -19121,6 +19307,7 @@
           <a:lstStyle xmlns:a="http://schemas.openxmlformats.org/drawingml/2006/main"/>
           <a:p xmlns:a="http://schemas.openxmlformats.org/drawingml/2006/main">
             <a:pPr algn="l">
+              <a:buNone/>
               <a:defRPr sz="1425" b="1">
                 <a:solidFill>
                   <a:srgbClr val="111318"/>
@@ -19173,6 +19360,7 @@
           <a:lstStyle xmlns:a="http://schemas.openxmlformats.org/drawingml/2006/main"/>
           <a:p xmlns:a="http://schemas.openxmlformats.org/drawingml/2006/main">
             <a:pPr algn="l">
+              <a:buNone/>
               <a:defRPr sz="1275" b="0">
                 <a:solidFill>
                   <a:srgbClr val="5E6572"/>
@@ -19225,6 +19413,7 @@
           <a:lstStyle xmlns:a="http://schemas.openxmlformats.org/drawingml/2006/main"/>
           <a:p xmlns:a="http://schemas.openxmlformats.org/drawingml/2006/main">
             <a:pPr algn="r">
+              <a:buNone/>
               <a:defRPr sz="1200" b="1">
                 <a:solidFill>
                   <a:srgbClr val="3D8DFF"/>
@@ -19310,6 +19499,7 @@
           <a:lstStyle xmlns:a="http://schemas.openxmlformats.org/drawingml/2006/main"/>
           <a:p xmlns:a="http://schemas.openxmlformats.org/drawingml/2006/main">
             <a:pPr algn="ctr">
+              <a:buNone/>
               <a:defRPr sz="1500" b="1">
                 <a:solidFill>
                   <a:srgbClr val="FFFFFF"/>
@@ -19362,6 +19552,7 @@
           <a:lstStyle xmlns:a="http://schemas.openxmlformats.org/drawingml/2006/main"/>
           <a:p xmlns:a="http://schemas.openxmlformats.org/drawingml/2006/main">
             <a:pPr algn="l">
+              <a:buNone/>
               <a:defRPr sz="1425" b="1">
                 <a:solidFill>
                   <a:srgbClr val="111318"/>
@@ -19414,6 +19605,7 @@
           <a:lstStyle xmlns:a="http://schemas.openxmlformats.org/drawingml/2006/main"/>
           <a:p xmlns:a="http://schemas.openxmlformats.org/drawingml/2006/main">
             <a:pPr algn="l">
+              <a:buNone/>
               <a:defRPr sz="1275" b="0">
                 <a:solidFill>
                   <a:srgbClr val="5E6572"/>
@@ -19466,6 +19658,7 @@
           <a:lstStyle xmlns:a="http://schemas.openxmlformats.org/drawingml/2006/main"/>
           <a:p xmlns:a="http://schemas.openxmlformats.org/drawingml/2006/main">
             <a:pPr algn="r">
+              <a:buNone/>
               <a:defRPr sz="1200" b="1">
                 <a:solidFill>
                   <a:srgbClr val="3D8DFF"/>
@@ -19551,6 +19744,7 @@
           <a:lstStyle xmlns:a="http://schemas.openxmlformats.org/drawingml/2006/main"/>
           <a:p xmlns:a="http://schemas.openxmlformats.org/drawingml/2006/main">
             <a:pPr algn="ctr">
+              <a:buNone/>
               <a:defRPr sz="1500" b="1">
                 <a:solidFill>
                   <a:srgbClr val="FFFFFF"/>
@@ -19603,6 +19797,7 @@
           <a:lstStyle xmlns:a="http://schemas.openxmlformats.org/drawingml/2006/main"/>
           <a:p xmlns:a="http://schemas.openxmlformats.org/drawingml/2006/main">
             <a:pPr algn="l">
+              <a:buNone/>
               <a:defRPr sz="1425" b="1">
                 <a:solidFill>
                   <a:srgbClr val="111318"/>
@@ -19655,6 +19850,7 @@
           <a:lstStyle xmlns:a="http://schemas.openxmlformats.org/drawingml/2006/main"/>
           <a:p xmlns:a="http://schemas.openxmlformats.org/drawingml/2006/main">
             <a:pPr algn="l">
+              <a:buNone/>
               <a:defRPr sz="1275" b="0">
                 <a:solidFill>
                   <a:srgbClr val="5E6572"/>
@@ -19707,6 +19903,7 @@
           <a:lstStyle xmlns:a="http://schemas.openxmlformats.org/drawingml/2006/main"/>
           <a:p xmlns:a="http://schemas.openxmlformats.org/drawingml/2006/main">
             <a:pPr algn="r">
+              <a:buNone/>
               <a:defRPr sz="1200" b="1">
                 <a:solidFill>
                   <a:srgbClr val="3D8DFF"/>
@@ -19792,6 +19989,7 @@
           <a:lstStyle xmlns:a="http://schemas.openxmlformats.org/drawingml/2006/main"/>
           <a:p xmlns:a="http://schemas.openxmlformats.org/drawingml/2006/main">
             <a:pPr algn="ctr">
+              <a:buNone/>
               <a:defRPr sz="1500" b="1">
                 <a:solidFill>
                   <a:srgbClr val="FFFFFF"/>
@@ -19844,6 +20042,7 @@
           <a:lstStyle xmlns:a="http://schemas.openxmlformats.org/drawingml/2006/main"/>
           <a:p xmlns:a="http://schemas.openxmlformats.org/drawingml/2006/main">
             <a:pPr algn="l">
+              <a:buNone/>
               <a:defRPr sz="1425" b="1">
                 <a:solidFill>
                   <a:srgbClr val="111318"/>
@@ -19896,6 +20095,7 @@
           <a:lstStyle xmlns:a="http://schemas.openxmlformats.org/drawingml/2006/main"/>
           <a:p xmlns:a="http://schemas.openxmlformats.org/drawingml/2006/main">
             <a:pPr algn="l">
+              <a:buNone/>
               <a:defRPr sz="1275" b="0">
                 <a:solidFill>
                   <a:srgbClr val="5E6572"/>
@@ -19948,6 +20148,7 @@
           <a:lstStyle xmlns:a="http://schemas.openxmlformats.org/drawingml/2006/main"/>
           <a:p xmlns:a="http://schemas.openxmlformats.org/drawingml/2006/main">
             <a:pPr algn="r">
+              <a:buNone/>
               <a:defRPr sz="1200" b="1">
                 <a:solidFill>
                   <a:srgbClr val="3D8DFF"/>
@@ -20033,6 +20234,7 @@
           <a:lstStyle xmlns:a="http://schemas.openxmlformats.org/drawingml/2006/main"/>
           <a:p xmlns:a="http://schemas.openxmlformats.org/drawingml/2006/main">
             <a:pPr algn="ctr">
+              <a:buNone/>
               <a:defRPr sz="1500" b="1">
                 <a:solidFill>
                   <a:srgbClr val="6DCBF4"/>
@@ -20085,6 +20287,7 @@
           <a:lstStyle xmlns:a="http://schemas.openxmlformats.org/drawingml/2006/main"/>
           <a:p xmlns:a="http://schemas.openxmlformats.org/drawingml/2006/main">
             <a:pPr algn="l">
+              <a:buNone/>
               <a:defRPr sz="1425" b="1">
                 <a:solidFill>
                   <a:srgbClr val="111318"/>
@@ -20137,6 +20340,7 @@
           <a:lstStyle xmlns:a="http://schemas.openxmlformats.org/drawingml/2006/main"/>
           <a:p xmlns:a="http://schemas.openxmlformats.org/drawingml/2006/main">
             <a:pPr algn="l">
+              <a:buNone/>
               <a:defRPr sz="1275" b="0">
                 <a:solidFill>
                   <a:srgbClr val="5E6572"/>
@@ -20189,6 +20393,7 @@
           <a:lstStyle xmlns:a="http://schemas.openxmlformats.org/drawingml/2006/main"/>
           <a:p xmlns:a="http://schemas.openxmlformats.org/drawingml/2006/main">
             <a:pPr algn="r">
+              <a:buNone/>
               <a:defRPr sz="1200" b="1">
                 <a:solidFill>
                   <a:srgbClr val="3D8DFF"/>
@@ -20274,6 +20479,7 @@
           <a:lstStyle xmlns:a="http://schemas.openxmlformats.org/drawingml/2006/main"/>
           <a:p xmlns:a="http://schemas.openxmlformats.org/drawingml/2006/main">
             <a:pPr algn="ctr">
+              <a:buNone/>
               <a:defRPr sz="1350" b="1">
                 <a:solidFill>
                   <a:srgbClr val="2D9D78"/>
@@ -20355,6 +20561,7 @@
           <a:lstStyle xmlns:a="http://schemas.openxmlformats.org/drawingml/2006/main"/>
           <a:p xmlns:a="http://schemas.openxmlformats.org/drawingml/2006/main">
             <a:pPr algn="l">
+              <a:buNone/>
               <a:defRPr sz="975" b="1">
                 <a:solidFill>
                   <a:srgbClr val="3D8DFF"/>
@@ -20407,6 +20614,7 @@
           <a:lstStyle xmlns:a="http://schemas.openxmlformats.org/drawingml/2006/main"/>
           <a:p xmlns:a="http://schemas.openxmlformats.org/drawingml/2006/main">
             <a:pPr algn="l">
+              <a:buNone/>
               <a:defRPr sz="3000" b="1">
                 <a:solidFill>
                   <a:srgbClr val="111318"/>
@@ -20490,6 +20698,7 @@
           <a:lstStyle xmlns:a="http://schemas.openxmlformats.org/drawingml/2006/main"/>
           <a:p xmlns:a="http://schemas.openxmlformats.org/drawingml/2006/main">
             <a:pPr algn="r">
+              <a:buNone/>
               <a:defRPr sz="975" b="0">
                 <a:solidFill>
                   <a:srgbClr val="8F96A3"/>
@@ -20542,6 +20751,7 @@
           <a:lstStyle xmlns:a="http://schemas.openxmlformats.org/drawingml/2006/main"/>
           <a:p xmlns:a="http://schemas.openxmlformats.org/drawingml/2006/main">
             <a:pPr algn="l">
+              <a:buNone/>
               <a:defRPr sz="1875" b="1">
                 <a:solidFill>
                   <a:srgbClr val="0E3A66"/>
@@ -20658,6 +20868,7 @@
           <a:lstStyle xmlns:a="http://schemas.openxmlformats.org/drawingml/2006/main"/>
           <a:p xmlns:a="http://schemas.openxmlformats.org/drawingml/2006/main">
             <a:pPr algn="ctr">
+              <a:buNone/>
               <a:defRPr sz="1500" b="1">
                 <a:solidFill>
                   <a:srgbClr val="FFFFFF"/>
@@ -20710,6 +20921,7 @@
           <a:lstStyle xmlns:a="http://schemas.openxmlformats.org/drawingml/2006/main"/>
           <a:p xmlns:a="http://schemas.openxmlformats.org/drawingml/2006/main">
             <a:pPr algn="l">
+              <a:buNone/>
               <a:defRPr sz="1725" b="1">
                 <a:solidFill>
                   <a:srgbClr val="111318"/>
@@ -20762,6 +20974,7 @@
           <a:lstStyle xmlns:a="http://schemas.openxmlformats.org/drawingml/2006/main"/>
           <a:p xmlns:a="http://schemas.openxmlformats.org/drawingml/2006/main">
             <a:pPr algn="l">
+              <a:buNone/>
               <a:defRPr sz="1350" b="0">
                 <a:solidFill>
                   <a:srgbClr val="5E6572"/>
@@ -20940,6 +21153,7 @@
           <a:lstStyle xmlns:a="http://schemas.openxmlformats.org/drawingml/2006/main"/>
           <a:p xmlns:a="http://schemas.openxmlformats.org/drawingml/2006/main">
             <a:pPr algn="ctr">
+              <a:buNone/>
               <a:defRPr sz="1500" b="1">
                 <a:solidFill>
                   <a:srgbClr val="FFFFFF"/>
@@ -20992,6 +21206,7 @@
           <a:lstStyle xmlns:a="http://schemas.openxmlformats.org/drawingml/2006/main"/>
           <a:p xmlns:a="http://schemas.openxmlformats.org/drawingml/2006/main">
             <a:pPr algn="l">
+              <a:buNone/>
               <a:defRPr sz="1725" b="1">
                 <a:solidFill>
                   <a:srgbClr val="111318"/>
@@ -21044,6 +21259,7 @@
           <a:lstStyle xmlns:a="http://schemas.openxmlformats.org/drawingml/2006/main"/>
           <a:p xmlns:a="http://schemas.openxmlformats.org/drawingml/2006/main">
             <a:pPr algn="l">
+              <a:buNone/>
               <a:defRPr sz="1350" b="0">
                 <a:solidFill>
                   <a:srgbClr val="5E6572"/>
@@ -21222,6 +21438,7 @@
           <a:lstStyle xmlns:a="http://schemas.openxmlformats.org/drawingml/2006/main"/>
           <a:p xmlns:a="http://schemas.openxmlformats.org/drawingml/2006/main">
             <a:pPr algn="ctr">
+              <a:buNone/>
               <a:defRPr sz="1500" b="1">
                 <a:solidFill>
                   <a:srgbClr val="FFFFFF"/>
@@ -21274,6 +21491,7 @@
           <a:lstStyle xmlns:a="http://schemas.openxmlformats.org/drawingml/2006/main"/>
           <a:p xmlns:a="http://schemas.openxmlformats.org/drawingml/2006/main">
             <a:pPr algn="l">
+              <a:buNone/>
               <a:defRPr sz="1725" b="1">
                 <a:solidFill>
                   <a:srgbClr val="111318"/>
@@ -21326,6 +21544,7 @@
           <a:lstStyle xmlns:a="http://schemas.openxmlformats.org/drawingml/2006/main"/>
           <a:p xmlns:a="http://schemas.openxmlformats.org/drawingml/2006/main">
             <a:pPr algn="l">
+              <a:buNone/>
               <a:defRPr sz="1350" b="0">
                 <a:solidFill>
                   <a:srgbClr val="5E6572"/>
@@ -21411,6 +21630,7 @@
           <a:lstStyle xmlns:a="http://schemas.openxmlformats.org/drawingml/2006/main"/>
           <a:p xmlns:a="http://schemas.openxmlformats.org/drawingml/2006/main">
             <a:pPr algn="l">
+              <a:buNone/>
               <a:defRPr sz="1350" b="1">
                 <a:solidFill>
                   <a:srgbClr val="6DCBF4"/>
@@ -21463,6 +21683,7 @@
           <a:lstStyle xmlns:a="http://schemas.openxmlformats.org/drawingml/2006/main"/>
           <a:p xmlns:a="http://schemas.openxmlformats.org/drawingml/2006/main">
             <a:pPr algn="l">
+              <a:buNone/>
               <a:defRPr sz="1650" b="1">
                 <a:solidFill>
                   <a:srgbClr val="FFFFFF"/>
@@ -21544,6 +21765,7 @@
           <a:lstStyle xmlns:a="http://schemas.openxmlformats.org/drawingml/2006/main"/>
           <a:p xmlns:a="http://schemas.openxmlformats.org/drawingml/2006/main">
             <a:pPr algn="l">
+              <a:buNone/>
               <a:defRPr sz="975" b="1">
                 <a:solidFill>
                   <a:srgbClr val="3D8DFF"/>
@@ -21596,6 +21818,7 @@
           <a:lstStyle xmlns:a="http://schemas.openxmlformats.org/drawingml/2006/main"/>
           <a:p xmlns:a="http://schemas.openxmlformats.org/drawingml/2006/main">
             <a:pPr algn="l">
+              <a:buNone/>
               <a:defRPr sz="3000" b="1">
                 <a:solidFill>
                   <a:srgbClr val="111318"/>
@@ -21679,6 +21902,7 @@
           <a:lstStyle xmlns:a="http://schemas.openxmlformats.org/drawingml/2006/main"/>
           <a:p xmlns:a="http://schemas.openxmlformats.org/drawingml/2006/main">
             <a:pPr algn="r">
+              <a:buNone/>
               <a:defRPr sz="975" b="0">
                 <a:solidFill>
                   <a:srgbClr val="8F96A3"/>
@@ -21797,6 +22021,7 @@
           <a:lstStyle xmlns:a="http://schemas.openxmlformats.org/drawingml/2006/main"/>
           <a:p xmlns:a="http://schemas.openxmlformats.org/drawingml/2006/main">
             <a:pPr algn="ctr">
+              <a:buNone/>
               <a:defRPr sz="1050" b="1">
                 <a:solidFill>
                   <a:srgbClr val="FFFFFF"/>
@@ -21849,6 +22074,7 @@
           <a:lstStyle xmlns:a="http://schemas.openxmlformats.org/drawingml/2006/main"/>
           <a:p xmlns:a="http://schemas.openxmlformats.org/drawingml/2006/main">
             <a:pPr algn="l">
+              <a:buNone/>
               <a:defRPr sz="2250" b="1">
                 <a:solidFill>
                   <a:srgbClr val="111318"/>
@@ -21901,6 +22127,7 @@
           <a:lstStyle xmlns:a="http://schemas.openxmlformats.org/drawingml/2006/main"/>
           <a:p xmlns:a="http://schemas.openxmlformats.org/drawingml/2006/main">
             <a:pPr algn="l">
+              <a:buNone/>
               <a:defRPr sz="1350" b="1">
                 <a:solidFill>
                   <a:srgbClr val="3D8DFF"/>
@@ -21953,6 +22180,7 @@
           <a:lstStyle xmlns:a="http://schemas.openxmlformats.org/drawingml/2006/main"/>
           <a:p xmlns:a="http://schemas.openxmlformats.org/drawingml/2006/main">
             <a:pPr algn="l">
+              <a:buNone/>
               <a:defRPr sz="1350" b="0">
                 <a:solidFill>
                   <a:srgbClr val="5E6572"/>
@@ -22005,6 +22233,7 @@
           <a:lstStyle xmlns:a="http://schemas.openxmlformats.org/drawingml/2006/main"/>
           <a:p xmlns:a="http://schemas.openxmlformats.org/drawingml/2006/main">
             <a:pPr algn="l">
+              <a:buNone/>
               <a:defRPr sz="1350" b="1">
                 <a:solidFill>
                   <a:srgbClr val="E3545B"/>
@@ -22057,6 +22286,7 @@
           <a:lstStyle xmlns:a="http://schemas.openxmlformats.org/drawingml/2006/main"/>
           <a:p xmlns:a="http://schemas.openxmlformats.org/drawingml/2006/main">
             <a:pPr algn="l">
+              <a:buNone/>
               <a:defRPr sz="1350" b="0">
                 <a:solidFill>
                   <a:srgbClr val="5E6572"/>
@@ -22109,6 +22339,7 @@
           <a:lstStyle xmlns:a="http://schemas.openxmlformats.org/drawingml/2006/main"/>
           <a:p xmlns:a="http://schemas.openxmlformats.org/drawingml/2006/main">
             <a:pPr algn="l">
+              <a:buNone/>
               <a:defRPr sz="1350" b="1">
                 <a:solidFill>
                   <a:srgbClr val="2D9D78"/>
@@ -22161,6 +22392,7 @@
           <a:lstStyle xmlns:a="http://schemas.openxmlformats.org/drawingml/2006/main"/>
           <a:p xmlns:a="http://schemas.openxmlformats.org/drawingml/2006/main">
             <a:pPr algn="l">
+              <a:buNone/>
               <a:defRPr sz="1350" b="0">
                 <a:solidFill>
                   <a:srgbClr val="5E6572"/>
@@ -22279,6 +22511,7 @@
           <a:lstStyle xmlns:a="http://schemas.openxmlformats.org/drawingml/2006/main"/>
           <a:p xmlns:a="http://schemas.openxmlformats.org/drawingml/2006/main">
             <a:pPr algn="l">
+              <a:buNone/>
               <a:defRPr sz="1575" b="1">
                 <a:solidFill>
                   <a:srgbClr val="111318"/>
@@ -22331,6 +22564,7 @@
           <a:lstStyle xmlns:a="http://schemas.openxmlformats.org/drawingml/2006/main"/>
           <a:p xmlns:a="http://schemas.openxmlformats.org/drawingml/2006/main">
             <a:pPr algn="l">
+              <a:buNone/>
               <a:defRPr sz="1275" b="0">
                 <a:solidFill>
                   <a:srgbClr val="5E6572"/>
@@ -22449,6 +22683,7 @@
           <a:lstStyle xmlns:a="http://schemas.openxmlformats.org/drawingml/2006/main"/>
           <a:p xmlns:a="http://schemas.openxmlformats.org/drawingml/2006/main">
             <a:pPr algn="l">
+              <a:buNone/>
               <a:defRPr sz="1575" b="1">
                 <a:solidFill>
                   <a:srgbClr val="111318"/>
@@ -22501,6 +22736,7 @@
           <a:lstStyle xmlns:a="http://schemas.openxmlformats.org/drawingml/2006/main"/>
           <a:p xmlns:a="http://schemas.openxmlformats.org/drawingml/2006/main">
             <a:pPr algn="l">
+              <a:buNone/>
               <a:defRPr sz="1275" b="0">
                 <a:solidFill>
                   <a:srgbClr val="5E6572"/>
@@ -22582,6 +22818,7 @@
           <a:lstStyle xmlns:a="http://schemas.openxmlformats.org/drawingml/2006/main"/>
           <a:p xmlns:a="http://schemas.openxmlformats.org/drawingml/2006/main">
             <a:pPr algn="l">
+              <a:buNone/>
               <a:defRPr sz="975" b="1">
                 <a:solidFill>
                   <a:srgbClr val="3D8DFF"/>
@@ -22634,6 +22871,7 @@
           <a:lstStyle xmlns:a="http://schemas.openxmlformats.org/drawingml/2006/main"/>
           <a:p xmlns:a="http://schemas.openxmlformats.org/drawingml/2006/main">
             <a:pPr algn="l">
+              <a:buNone/>
               <a:defRPr sz="3000" b="1">
                 <a:solidFill>
                   <a:srgbClr val="111318"/>
@@ -22717,6 +22955,7 @@
           <a:lstStyle xmlns:a="http://schemas.openxmlformats.org/drawingml/2006/main"/>
           <a:p xmlns:a="http://schemas.openxmlformats.org/drawingml/2006/main">
             <a:pPr algn="r">
+              <a:buNone/>
               <a:defRPr sz="975" b="0">
                 <a:solidFill>
                   <a:srgbClr val="8F96A3"/>
@@ -22802,6 +23041,7 @@
           <a:lstStyle xmlns:a="http://schemas.openxmlformats.org/drawingml/2006/main"/>
           <a:p xmlns:a="http://schemas.openxmlformats.org/drawingml/2006/main">
             <a:pPr algn="ctr">
+              <a:buNone/>
               <a:defRPr sz="1800" b="1">
                 <a:solidFill>
                   <a:srgbClr val="FFFFFF"/>
@@ -22885,6 +23125,7 @@
           <a:lstStyle xmlns:a="http://schemas.openxmlformats.org/drawingml/2006/main"/>
           <a:p xmlns:a="http://schemas.openxmlformats.org/drawingml/2006/main">
             <a:pPr algn="ctr">
+              <a:buNone/>
               <a:defRPr sz="1500" b="1">
                 <a:solidFill>
                   <a:srgbClr val="FFFFFF"/>
@@ -22937,6 +23178,7 @@
           <a:lstStyle xmlns:a="http://schemas.openxmlformats.org/drawingml/2006/main"/>
           <a:p xmlns:a="http://schemas.openxmlformats.org/drawingml/2006/main">
             <a:pPr algn="l">
+              <a:buNone/>
               <a:defRPr sz="1575" b="1">
                 <a:solidFill>
                   <a:srgbClr val="111318"/>
@@ -22989,6 +23231,7 @@
           <a:lstStyle xmlns:a="http://schemas.openxmlformats.org/drawingml/2006/main"/>
           <a:p xmlns:a="http://schemas.openxmlformats.org/drawingml/2006/main">
             <a:pPr algn="l">
+              <a:buNone/>
               <a:defRPr sz="1275" b="0">
                 <a:solidFill>
                   <a:srgbClr val="5E6572"/>
@@ -23134,6 +23377,7 @@
           <a:lstStyle xmlns:a="http://schemas.openxmlformats.org/drawingml/2006/main"/>
           <a:p xmlns:a="http://schemas.openxmlformats.org/drawingml/2006/main">
             <a:pPr algn="ctr">
+              <a:buNone/>
               <a:defRPr sz="1500" b="1">
                 <a:solidFill>
                   <a:srgbClr val="FFFFFF"/>
@@ -23186,6 +23430,7 @@
           <a:lstStyle xmlns:a="http://schemas.openxmlformats.org/drawingml/2006/main"/>
           <a:p xmlns:a="http://schemas.openxmlformats.org/drawingml/2006/main">
             <a:pPr algn="l">
+              <a:buNone/>
               <a:defRPr sz="1575" b="1">
                 <a:solidFill>
                   <a:srgbClr val="111318"/>
@@ -23238,6 +23483,7 @@
           <a:lstStyle xmlns:a="http://schemas.openxmlformats.org/drawingml/2006/main"/>
           <a:p xmlns:a="http://schemas.openxmlformats.org/drawingml/2006/main">
             <a:pPr algn="l">
+              <a:buNone/>
               <a:defRPr sz="1275" b="0">
                 <a:solidFill>
                   <a:srgbClr val="5E6572"/>
@@ -23383,6 +23629,7 @@
           <a:lstStyle xmlns:a="http://schemas.openxmlformats.org/drawingml/2006/main"/>
           <a:p xmlns:a="http://schemas.openxmlformats.org/drawingml/2006/main">
             <a:pPr algn="ctr">
+              <a:buNone/>
               <a:defRPr sz="1500" b="1">
                 <a:solidFill>
                   <a:srgbClr val="FFFFFF"/>
@@ -23435,6 +23682,7 @@
           <a:lstStyle xmlns:a="http://schemas.openxmlformats.org/drawingml/2006/main"/>
           <a:p xmlns:a="http://schemas.openxmlformats.org/drawingml/2006/main">
             <a:pPr algn="l">
+              <a:buNone/>
               <a:defRPr sz="1575" b="1">
                 <a:solidFill>
                   <a:srgbClr val="111318"/>
@@ -23487,6 +23735,7 @@
           <a:lstStyle xmlns:a="http://schemas.openxmlformats.org/drawingml/2006/main"/>
           <a:p xmlns:a="http://schemas.openxmlformats.org/drawingml/2006/main">
             <a:pPr algn="l">
+              <a:buNone/>
               <a:defRPr sz="1275" b="0">
                 <a:solidFill>
                   <a:srgbClr val="5E6572"/>
@@ -23632,6 +23881,7 @@
           <a:lstStyle xmlns:a="http://schemas.openxmlformats.org/drawingml/2006/main"/>
           <a:p xmlns:a="http://schemas.openxmlformats.org/drawingml/2006/main">
             <a:pPr algn="ctr">
+              <a:buNone/>
               <a:defRPr sz="1500" b="1">
                 <a:solidFill>
                   <a:srgbClr val="FFFFFF"/>
@@ -23684,6 +23934,7 @@
           <a:lstStyle xmlns:a="http://schemas.openxmlformats.org/drawingml/2006/main"/>
           <a:p xmlns:a="http://schemas.openxmlformats.org/drawingml/2006/main">
             <a:pPr algn="l">
+              <a:buNone/>
               <a:defRPr sz="1575" b="1">
                 <a:solidFill>
                   <a:srgbClr val="111318"/>
@@ -23736,6 +23987,7 @@
           <a:lstStyle xmlns:a="http://schemas.openxmlformats.org/drawingml/2006/main"/>
           <a:p xmlns:a="http://schemas.openxmlformats.org/drawingml/2006/main">
             <a:pPr algn="l">
+              <a:buNone/>
               <a:defRPr sz="1275" b="0">
                 <a:solidFill>
                   <a:srgbClr val="5E6572"/>
@@ -23788,6 +24040,7 @@
           <a:lstStyle xmlns:a="http://schemas.openxmlformats.org/drawingml/2006/main"/>
           <a:p xmlns:a="http://schemas.openxmlformats.org/drawingml/2006/main">
             <a:pPr algn="l">
+              <a:buNone/>
               <a:defRPr sz="1350" b="1">
                 <a:solidFill>
                   <a:srgbClr val="E3545B"/>
@@ -23840,6 +24093,7 @@
           <a:lstStyle xmlns:a="http://schemas.openxmlformats.org/drawingml/2006/main"/>
           <a:p xmlns:a="http://schemas.openxmlformats.org/drawingml/2006/main">
             <a:pPr algn="l">
+              <a:buNone/>
               <a:defRPr sz="1575" b="1">
                 <a:solidFill>
                   <a:srgbClr val="111318"/>
@@ -23921,6 +24175,7 @@
           <a:lstStyle xmlns:a="http://schemas.openxmlformats.org/drawingml/2006/main"/>
           <a:p xmlns:a="http://schemas.openxmlformats.org/drawingml/2006/main">
             <a:pPr algn="l">
+              <a:buNone/>
               <a:defRPr sz="975" b="1">
                 <a:solidFill>
                   <a:srgbClr val="3D8DFF"/>
@@ -23973,6 +24228,7 @@
           <a:lstStyle xmlns:a="http://schemas.openxmlformats.org/drawingml/2006/main"/>
           <a:p xmlns:a="http://schemas.openxmlformats.org/drawingml/2006/main">
             <a:pPr algn="l">
+              <a:buNone/>
               <a:defRPr sz="3000" b="1">
                 <a:solidFill>
                   <a:srgbClr val="111318"/>
@@ -24056,6 +24312,7 @@
           <a:lstStyle xmlns:a="http://schemas.openxmlformats.org/drawingml/2006/main"/>
           <a:p xmlns:a="http://schemas.openxmlformats.org/drawingml/2006/main">
             <a:pPr algn="r">
+              <a:buNone/>
               <a:defRPr sz="975" b="0">
                 <a:solidFill>
                   <a:srgbClr val="8F96A3"/>
@@ -24141,6 +24398,7 @@
           <a:lstStyle xmlns:a="http://schemas.openxmlformats.org/drawingml/2006/main"/>
           <a:p xmlns:a="http://schemas.openxmlformats.org/drawingml/2006/main">
             <a:pPr algn="l">
+              <a:buNone/>
               <a:defRPr sz="1125" b="1">
                 <a:solidFill>
                   <a:srgbClr val="FFFFFF"/>
@@ -24226,6 +24484,7 @@
           <a:lstStyle xmlns:a="http://schemas.openxmlformats.org/drawingml/2006/main"/>
           <a:p xmlns:a="http://schemas.openxmlformats.org/drawingml/2006/main">
             <a:pPr algn="l">
+              <a:buNone/>
               <a:defRPr sz="1125" b="1">
                 <a:solidFill>
                   <a:srgbClr val="FFFFFF"/>
@@ -24311,6 +24570,7 @@
           <a:lstStyle xmlns:a="http://schemas.openxmlformats.org/drawingml/2006/main"/>
           <a:p xmlns:a="http://schemas.openxmlformats.org/drawingml/2006/main">
             <a:pPr algn="l">
+              <a:buNone/>
               <a:defRPr sz="1125" b="1">
                 <a:solidFill>
                   <a:srgbClr val="FFFFFF"/>
@@ -24396,6 +24656,7 @@
           <a:lstStyle xmlns:a="http://schemas.openxmlformats.org/drawingml/2006/main"/>
           <a:p xmlns:a="http://schemas.openxmlformats.org/drawingml/2006/main">
             <a:pPr algn="l">
+              <a:buNone/>
               <a:defRPr sz="1125" b="1">
                 <a:solidFill>
                   <a:srgbClr val="FFFFFF"/>
@@ -24481,6 +24742,7 @@
           <a:lstStyle xmlns:a="http://schemas.openxmlformats.org/drawingml/2006/main"/>
           <a:p xmlns:a="http://schemas.openxmlformats.org/drawingml/2006/main">
             <a:pPr algn="l">
+              <a:buNone/>
               <a:defRPr sz="1125" b="1">
                 <a:solidFill>
                   <a:srgbClr val="FFFFFF"/>
@@ -24566,6 +24828,7 @@
           <a:lstStyle xmlns:a="http://schemas.openxmlformats.org/drawingml/2006/main"/>
           <a:p xmlns:a="http://schemas.openxmlformats.org/drawingml/2006/main">
             <a:pPr algn="l">
+              <a:buNone/>
               <a:defRPr sz="1125" b="1">
                 <a:solidFill>
                   <a:srgbClr val="FFFFFF"/>
@@ -24651,6 +24914,7 @@
           <a:lstStyle xmlns:a="http://schemas.openxmlformats.org/drawingml/2006/main"/>
           <a:p xmlns:a="http://schemas.openxmlformats.org/drawingml/2006/main">
             <a:pPr algn="l">
+              <a:buNone/>
               <a:defRPr sz="1200" b="0">
                 <a:solidFill>
                   <a:srgbClr val="111318"/>
@@ -24736,6 +25000,7 @@
           <a:lstStyle xmlns:a="http://schemas.openxmlformats.org/drawingml/2006/main"/>
           <a:p xmlns:a="http://schemas.openxmlformats.org/drawingml/2006/main">
             <a:pPr algn="l">
+              <a:buNone/>
               <a:defRPr sz="1200" b="0">
                 <a:solidFill>
                   <a:srgbClr val="111318"/>
@@ -24821,6 +25086,7 @@
           <a:lstStyle xmlns:a="http://schemas.openxmlformats.org/drawingml/2006/main"/>
           <a:p xmlns:a="http://schemas.openxmlformats.org/drawingml/2006/main">
             <a:pPr algn="l">
+              <a:buNone/>
               <a:defRPr sz="1200" b="0">
                 <a:solidFill>
                   <a:srgbClr val="111318"/>
@@ -24906,6 +25172,7 @@
           <a:lstStyle xmlns:a="http://schemas.openxmlformats.org/drawingml/2006/main"/>
           <a:p xmlns:a="http://schemas.openxmlformats.org/drawingml/2006/main">
             <a:pPr algn="l">
+              <a:buNone/>
               <a:defRPr sz="1200" b="0">
                 <a:solidFill>
                   <a:srgbClr val="111318"/>
@@ -24991,6 +25258,7 @@
           <a:lstStyle xmlns:a="http://schemas.openxmlformats.org/drawingml/2006/main"/>
           <a:p xmlns:a="http://schemas.openxmlformats.org/drawingml/2006/main">
             <a:pPr algn="l">
+              <a:buNone/>
               <a:defRPr sz="1200" b="0">
                 <a:solidFill>
                   <a:srgbClr val="111318"/>
@@ -25076,6 +25344,7 @@
           <a:lstStyle xmlns:a="http://schemas.openxmlformats.org/drawingml/2006/main"/>
           <a:p xmlns:a="http://schemas.openxmlformats.org/drawingml/2006/main">
             <a:pPr algn="l">
+              <a:buNone/>
               <a:defRPr sz="1200" b="0">
                 <a:solidFill>
                   <a:srgbClr val="111318"/>
@@ -25161,6 +25430,7 @@
           <a:lstStyle xmlns:a="http://schemas.openxmlformats.org/drawingml/2006/main"/>
           <a:p xmlns:a="http://schemas.openxmlformats.org/drawingml/2006/main">
             <a:pPr algn="l">
+              <a:buNone/>
               <a:defRPr sz="1200" b="0">
                 <a:solidFill>
                   <a:srgbClr val="111318"/>
@@ -25246,6 +25516,7 @@
           <a:lstStyle xmlns:a="http://schemas.openxmlformats.org/drawingml/2006/main"/>
           <a:p xmlns:a="http://schemas.openxmlformats.org/drawingml/2006/main">
             <a:pPr algn="l">
+              <a:buNone/>
               <a:defRPr sz="1200" b="0">
                 <a:solidFill>
                   <a:srgbClr val="111318"/>
@@ -25331,6 +25602,7 @@
           <a:lstStyle xmlns:a="http://schemas.openxmlformats.org/drawingml/2006/main"/>
           <a:p xmlns:a="http://schemas.openxmlformats.org/drawingml/2006/main">
             <a:pPr algn="l">
+              <a:buNone/>
               <a:defRPr sz="1200" b="0">
                 <a:solidFill>
                   <a:srgbClr val="111318"/>
@@ -25416,6 +25688,7 @@
           <a:lstStyle xmlns:a="http://schemas.openxmlformats.org/drawingml/2006/main"/>
           <a:p xmlns:a="http://schemas.openxmlformats.org/drawingml/2006/main">
             <a:pPr algn="l">
+              <a:buNone/>
               <a:defRPr sz="1200" b="0">
                 <a:solidFill>
                   <a:srgbClr val="111318"/>
@@ -25501,6 +25774,7 @@
           <a:lstStyle xmlns:a="http://schemas.openxmlformats.org/drawingml/2006/main"/>
           <a:p xmlns:a="http://schemas.openxmlformats.org/drawingml/2006/main">
             <a:pPr algn="l">
+              <a:buNone/>
               <a:defRPr sz="1200" b="0">
                 <a:solidFill>
                   <a:srgbClr val="111318"/>
@@ -25586,6 +25860,7 @@
           <a:lstStyle xmlns:a="http://schemas.openxmlformats.org/drawingml/2006/main"/>
           <a:p xmlns:a="http://schemas.openxmlformats.org/drawingml/2006/main">
             <a:pPr algn="l">
+              <a:buNone/>
               <a:defRPr sz="1200" b="0">
                 <a:solidFill>
                   <a:srgbClr val="111318"/>
@@ -25671,6 +25946,7 @@
           <a:lstStyle xmlns:a="http://schemas.openxmlformats.org/drawingml/2006/main"/>
           <a:p xmlns:a="http://schemas.openxmlformats.org/drawingml/2006/main">
             <a:pPr algn="l">
+              <a:buNone/>
               <a:defRPr sz="1200" b="0">
                 <a:solidFill>
                   <a:srgbClr val="111318"/>
@@ -25756,6 +26032,7 @@
           <a:lstStyle xmlns:a="http://schemas.openxmlformats.org/drawingml/2006/main"/>
           <a:p xmlns:a="http://schemas.openxmlformats.org/drawingml/2006/main">
             <a:pPr algn="l">
+              <a:buNone/>
               <a:defRPr sz="1200" b="0">
                 <a:solidFill>
                   <a:srgbClr val="111318"/>
@@ -25841,6 +26118,7 @@
           <a:lstStyle xmlns:a="http://schemas.openxmlformats.org/drawingml/2006/main"/>
           <a:p xmlns:a="http://schemas.openxmlformats.org/drawingml/2006/main">
             <a:pPr algn="l">
+              <a:buNone/>
               <a:defRPr sz="1200" b="0">
                 <a:solidFill>
                   <a:srgbClr val="111318"/>
@@ -25926,6 +26204,7 @@
           <a:lstStyle xmlns:a="http://schemas.openxmlformats.org/drawingml/2006/main"/>
           <a:p xmlns:a="http://schemas.openxmlformats.org/drawingml/2006/main">
             <a:pPr algn="l">
+              <a:buNone/>
               <a:defRPr sz="1200" b="0">
                 <a:solidFill>
                   <a:srgbClr val="111318"/>
@@ -26011,6 +26290,7 @@
           <a:lstStyle xmlns:a="http://schemas.openxmlformats.org/drawingml/2006/main"/>
           <a:p xmlns:a="http://schemas.openxmlformats.org/drawingml/2006/main">
             <a:pPr algn="l">
+              <a:buNone/>
               <a:defRPr sz="1200" b="0">
                 <a:solidFill>
                   <a:srgbClr val="111318"/>
@@ -26096,6 +26376,7 @@
           <a:lstStyle xmlns:a="http://schemas.openxmlformats.org/drawingml/2006/main"/>
           <a:p xmlns:a="http://schemas.openxmlformats.org/drawingml/2006/main">
             <a:pPr algn="l">
+              <a:buNone/>
               <a:defRPr sz="1200" b="0">
                 <a:solidFill>
                   <a:srgbClr val="111318"/>
@@ -26181,6 +26462,7 @@
           <a:lstStyle xmlns:a="http://schemas.openxmlformats.org/drawingml/2006/main"/>
           <a:p xmlns:a="http://schemas.openxmlformats.org/drawingml/2006/main">
             <a:pPr algn="l">
+              <a:buNone/>
               <a:defRPr sz="1200" b="0">
                 <a:solidFill>
                   <a:srgbClr val="111318"/>
@@ -26266,6 +26548,7 @@
           <a:lstStyle xmlns:a="http://schemas.openxmlformats.org/drawingml/2006/main"/>
           <a:p xmlns:a="http://schemas.openxmlformats.org/drawingml/2006/main">
             <a:pPr algn="l">
+              <a:buNone/>
               <a:defRPr sz="1200" b="0">
                 <a:solidFill>
                   <a:srgbClr val="111318"/>
@@ -26351,6 +26634,7 @@
           <a:lstStyle xmlns:a="http://schemas.openxmlformats.org/drawingml/2006/main"/>
           <a:p xmlns:a="http://schemas.openxmlformats.org/drawingml/2006/main">
             <a:pPr algn="l">
+              <a:buNone/>
               <a:defRPr sz="1200" b="0">
                 <a:solidFill>
                   <a:srgbClr val="111318"/>
@@ -26436,6 +26720,7 @@
           <a:lstStyle xmlns:a="http://schemas.openxmlformats.org/drawingml/2006/main"/>
           <a:p xmlns:a="http://schemas.openxmlformats.org/drawingml/2006/main">
             <a:pPr algn="l">
+              <a:buNone/>
               <a:defRPr sz="1200" b="0">
                 <a:solidFill>
                   <a:srgbClr val="111318"/>
@@ -26521,6 +26806,7 @@
           <a:lstStyle xmlns:a="http://schemas.openxmlformats.org/drawingml/2006/main"/>
           <a:p xmlns:a="http://schemas.openxmlformats.org/drawingml/2006/main">
             <a:pPr algn="l">
+              <a:buNone/>
               <a:defRPr sz="1200" b="0">
                 <a:solidFill>
                   <a:srgbClr val="111318"/>
@@ -26606,6 +26892,7 @@
           <a:lstStyle xmlns:a="http://schemas.openxmlformats.org/drawingml/2006/main"/>
           <a:p xmlns:a="http://schemas.openxmlformats.org/drawingml/2006/main">
             <a:pPr algn="l">
+              <a:buNone/>
               <a:defRPr sz="1200" b="0">
                 <a:solidFill>
                   <a:srgbClr val="111318"/>
@@ -26691,6 +26978,7 @@
           <a:lstStyle xmlns:a="http://schemas.openxmlformats.org/drawingml/2006/main"/>
           <a:p xmlns:a="http://schemas.openxmlformats.org/drawingml/2006/main">
             <a:pPr algn="l">
+              <a:buNone/>
               <a:defRPr sz="1200" b="1">
                 <a:solidFill>
                   <a:srgbClr val="111318"/>
@@ -26776,6 +27064,7 @@
           <a:lstStyle xmlns:a="http://schemas.openxmlformats.org/drawingml/2006/main"/>
           <a:p xmlns:a="http://schemas.openxmlformats.org/drawingml/2006/main">
             <a:pPr algn="l">
+              <a:buNone/>
               <a:defRPr sz="1200" b="1">
                 <a:solidFill>
                   <a:srgbClr val="111318"/>
@@ -26861,6 +27150,7 @@
           <a:lstStyle xmlns:a="http://schemas.openxmlformats.org/drawingml/2006/main"/>
           <a:p xmlns:a="http://schemas.openxmlformats.org/drawingml/2006/main">
             <a:pPr algn="l">
+              <a:buNone/>
               <a:defRPr sz="1200" b="1">
                 <a:solidFill>
                   <a:srgbClr val="111318"/>
@@ -26946,6 +27236,7 @@
           <a:lstStyle xmlns:a="http://schemas.openxmlformats.org/drawingml/2006/main"/>
           <a:p xmlns:a="http://schemas.openxmlformats.org/drawingml/2006/main">
             <a:pPr algn="l">
+              <a:buNone/>
               <a:defRPr sz="1200" b="1">
                 <a:solidFill>
                   <a:srgbClr val="111318"/>
@@ -27031,6 +27322,7 @@
           <a:lstStyle xmlns:a="http://schemas.openxmlformats.org/drawingml/2006/main"/>
           <a:p xmlns:a="http://schemas.openxmlformats.org/drawingml/2006/main">
             <a:pPr algn="l">
+              <a:buNone/>
               <a:defRPr sz="1200" b="1">
                 <a:solidFill>
                   <a:srgbClr val="111318"/>
@@ -27116,6 +27408,7 @@
           <a:lstStyle xmlns:a="http://schemas.openxmlformats.org/drawingml/2006/main"/>
           <a:p xmlns:a="http://schemas.openxmlformats.org/drawingml/2006/main">
             <a:pPr algn="l">
+              <a:buNone/>
               <a:defRPr sz="1200" b="0">
                 <a:solidFill>
                   <a:srgbClr val="111318"/>
@@ -27168,6 +27461,7 @@
           <a:lstStyle xmlns:a="http://schemas.openxmlformats.org/drawingml/2006/main"/>
           <a:p xmlns:a="http://schemas.openxmlformats.org/drawingml/2006/main">
             <a:pPr algn="l">
+              <a:buNone/>
               <a:defRPr sz="1050" b="0">
                 <a:solidFill>
                   <a:srgbClr val="8F96A3"/>
@@ -27220,6 +27514,7 @@
           <a:lstStyle xmlns:a="http://schemas.openxmlformats.org/drawingml/2006/main"/>
           <a:p xmlns:a="http://schemas.openxmlformats.org/drawingml/2006/main">
             <a:pPr algn="l">
+              <a:buNone/>
               <a:defRPr sz="1275" b="1">
                 <a:solidFill>
                   <a:srgbClr val="0E3A66"/>
@@ -27301,6 +27596,7 @@
           <a:lstStyle xmlns:a="http://schemas.openxmlformats.org/drawingml/2006/main"/>
           <a:p xmlns:a="http://schemas.openxmlformats.org/drawingml/2006/main">
             <a:pPr algn="l">
+              <a:buNone/>
               <a:defRPr sz="975" b="1">
                 <a:solidFill>
                   <a:srgbClr val="3D8DFF"/>
@@ -27353,6 +27649,7 @@
           <a:lstStyle xmlns:a="http://schemas.openxmlformats.org/drawingml/2006/main"/>
           <a:p xmlns:a="http://schemas.openxmlformats.org/drawingml/2006/main">
             <a:pPr algn="l">
+              <a:buNone/>
               <a:defRPr sz="3000" b="1">
                 <a:solidFill>
                   <a:srgbClr val="111318"/>
@@ -27436,6 +27733,7 @@
           <a:lstStyle xmlns:a="http://schemas.openxmlformats.org/drawingml/2006/main"/>
           <a:p xmlns:a="http://schemas.openxmlformats.org/drawingml/2006/main">
             <a:pPr algn="r">
+              <a:buNone/>
               <a:defRPr sz="975" b="0">
                 <a:solidFill>
                   <a:srgbClr val="8F96A3"/>
@@ -27488,6 +27786,7 @@
           <a:lstStyle xmlns:a="http://schemas.openxmlformats.org/drawingml/2006/main"/>
           <a:p xmlns:a="http://schemas.openxmlformats.org/drawingml/2006/main">
             <a:pPr algn="l">
+              <a:buNone/>
               <a:defRPr sz="1875" b="1">
                 <a:solidFill>
                   <a:srgbClr val="0E3A66"/>
@@ -27573,6 +27872,7 @@
           <a:lstStyle xmlns:a="http://schemas.openxmlformats.org/drawingml/2006/main"/>
           <a:p xmlns:a="http://schemas.openxmlformats.org/drawingml/2006/main">
             <a:pPr algn="ctr">
+              <a:buNone/>
               <a:defRPr sz="2400" b="1">
                 <a:solidFill>
                   <a:srgbClr val="FFFFFF"/>
@@ -27625,6 +27925,7 @@
           <a:lstStyle xmlns:a="http://schemas.openxmlformats.org/drawingml/2006/main"/>
           <a:p xmlns:a="http://schemas.openxmlformats.org/drawingml/2006/main">
             <a:pPr algn="ctr">
+              <a:buNone/>
               <a:defRPr sz="1650" b="1">
                 <a:solidFill>
                   <a:srgbClr val="FFFFFF"/>
@@ -27642,6 +27943,7 @@
           </a:p>
           <a:p xmlns:a="http://schemas.openxmlformats.org/drawingml/2006/main">
             <a:pPr algn="ctr">
+              <a:buNone/>
               <a:defRPr sz="1650" b="1">
                 <a:solidFill>
                   <a:srgbClr val="FFFFFF"/>
@@ -27694,6 +27996,7 @@
           <a:lstStyle xmlns:a="http://schemas.openxmlformats.org/drawingml/2006/main"/>
           <a:p xmlns:a="http://schemas.openxmlformats.org/drawingml/2006/main">
             <a:pPr algn="ctr">
+              <a:buNone/>
               <a:defRPr sz="1275" b="0">
                 <a:solidFill>
                   <a:srgbClr val="FFFFFF"/>
@@ -27812,6 +28115,7 @@
           <a:lstStyle xmlns:a="http://schemas.openxmlformats.org/drawingml/2006/main"/>
           <a:p xmlns:a="http://schemas.openxmlformats.org/drawingml/2006/main">
             <a:pPr algn="l">
+              <a:buNone/>
               <a:defRPr sz="1575" b="1">
                 <a:solidFill>
                   <a:srgbClr val="111318"/>
@@ -27864,6 +28168,7 @@
           <a:lstStyle xmlns:a="http://schemas.openxmlformats.org/drawingml/2006/main"/>
           <a:p xmlns:a="http://schemas.openxmlformats.org/drawingml/2006/main">
             <a:pPr algn="l">
+              <a:buNone/>
               <a:defRPr sz="1200" b="0">
                 <a:solidFill>
                   <a:srgbClr val="5E6572"/>
@@ -27982,6 +28287,7 @@
           <a:lstStyle xmlns:a="http://schemas.openxmlformats.org/drawingml/2006/main"/>
           <a:p xmlns:a="http://schemas.openxmlformats.org/drawingml/2006/main">
             <a:pPr algn="l">
+              <a:buNone/>
               <a:defRPr sz="1575" b="1">
                 <a:solidFill>
                   <a:srgbClr val="111318"/>
@@ -28034,6 +28340,7 @@
           <a:lstStyle xmlns:a="http://schemas.openxmlformats.org/drawingml/2006/main"/>
           <a:p xmlns:a="http://schemas.openxmlformats.org/drawingml/2006/main">
             <a:pPr algn="l">
+              <a:buNone/>
               <a:defRPr sz="1200" b="0">
                 <a:solidFill>
                   <a:srgbClr val="5E6572"/>
@@ -28152,6 +28459,7 @@
           <a:lstStyle xmlns:a="http://schemas.openxmlformats.org/drawingml/2006/main"/>
           <a:p xmlns:a="http://schemas.openxmlformats.org/drawingml/2006/main">
             <a:pPr algn="l">
+              <a:buNone/>
               <a:defRPr sz="1575" b="1">
                 <a:solidFill>
                   <a:srgbClr val="111318"/>
@@ -28204,6 +28512,7 @@
           <a:lstStyle xmlns:a="http://schemas.openxmlformats.org/drawingml/2006/main"/>
           <a:p xmlns:a="http://schemas.openxmlformats.org/drawingml/2006/main">
             <a:pPr algn="l">
+              <a:buNone/>
               <a:defRPr sz="1200" b="0">
                 <a:solidFill>
                   <a:srgbClr val="5E6572"/>
@@ -28322,6 +28631,7 @@
           <a:lstStyle xmlns:a="http://schemas.openxmlformats.org/drawingml/2006/main"/>
           <a:p xmlns:a="http://schemas.openxmlformats.org/drawingml/2006/main">
             <a:pPr algn="l">
+              <a:buNone/>
               <a:defRPr sz="1575" b="1">
                 <a:solidFill>
                   <a:srgbClr val="111318"/>
@@ -28374,6 +28684,7 @@
           <a:lstStyle xmlns:a="http://schemas.openxmlformats.org/drawingml/2006/main"/>
           <a:p xmlns:a="http://schemas.openxmlformats.org/drawingml/2006/main">
             <a:pPr algn="l">
+              <a:buNone/>
               <a:defRPr sz="1200" b="0">
                 <a:solidFill>
                   <a:srgbClr val="5E6572"/>
@@ -28455,6 +28766,7 @@
           <a:lstStyle xmlns:a="http://schemas.openxmlformats.org/drawingml/2006/main"/>
           <a:p xmlns:a="http://schemas.openxmlformats.org/drawingml/2006/main">
             <a:pPr algn="l">
+              <a:buNone/>
               <a:defRPr sz="975" b="1">
                 <a:solidFill>
                   <a:srgbClr val="3D8DFF"/>
@@ -28507,6 +28819,7 @@
           <a:lstStyle xmlns:a="http://schemas.openxmlformats.org/drawingml/2006/main"/>
           <a:p xmlns:a="http://schemas.openxmlformats.org/drawingml/2006/main">
             <a:pPr algn="l">
+              <a:buNone/>
               <a:defRPr sz="3000" b="1">
                 <a:solidFill>
                   <a:srgbClr val="111318"/>
@@ -28590,6 +28903,7 @@
           <a:lstStyle xmlns:a="http://schemas.openxmlformats.org/drawingml/2006/main"/>
           <a:p xmlns:a="http://schemas.openxmlformats.org/drawingml/2006/main">
             <a:pPr algn="r">
+              <a:buNone/>
               <a:defRPr sz="975" b="0">
                 <a:solidFill>
                   <a:srgbClr val="8F96A3"/>
@@ -28675,6 +28989,7 @@
           <a:lstStyle xmlns:a="http://schemas.openxmlformats.org/drawingml/2006/main"/>
           <a:p xmlns:a="http://schemas.openxmlformats.org/drawingml/2006/main">
             <a:pPr algn="l">
+              <a:buNone/>
               <a:defRPr sz="1350" b="1">
                 <a:solidFill>
                   <a:srgbClr val="3D8DFF"/>
@@ -28727,6 +29042,7 @@
           <a:lstStyle xmlns:a="http://schemas.openxmlformats.org/drawingml/2006/main"/>
           <a:p xmlns:a="http://schemas.openxmlformats.org/drawingml/2006/main">
             <a:pPr algn="l">
+              <a:buNone/>
               <a:defRPr sz="1650" b="1">
                 <a:solidFill>
                   <a:srgbClr val="0E3A66"/>
@@ -28812,6 +29128,7 @@
           <a:lstStyle xmlns:a="http://schemas.openxmlformats.org/drawingml/2006/main"/>
           <a:p xmlns:a="http://schemas.openxmlformats.org/drawingml/2006/main">
             <a:pPr algn="l">
+              <a:buNone/>
               <a:defRPr sz="1350" b="1">
                 <a:solidFill>
                   <a:srgbClr val="3D8DFF"/>
@@ -28864,6 +29181,7 @@
           <a:lstStyle xmlns:a="http://schemas.openxmlformats.org/drawingml/2006/main"/>
           <a:p xmlns:a="http://schemas.openxmlformats.org/drawingml/2006/main">
             <a:pPr algn="l">
+              <a:buNone/>
               <a:defRPr sz="1500" b="1">
                 <a:solidFill>
                   <a:srgbClr val="111318"/>
@@ -28916,6 +29234,7 @@
           <a:lstStyle xmlns:a="http://schemas.openxmlformats.org/drawingml/2006/main"/>
           <a:p xmlns:a="http://schemas.openxmlformats.org/drawingml/2006/main">
             <a:pPr algn="l">
+              <a:buNone/>
               <a:defRPr sz="1275" b="0">
                 <a:solidFill>
                   <a:srgbClr val="5E6572"/>
@@ -29063,6 +29382,7 @@
           <a:lstStyle xmlns:a="http://schemas.openxmlformats.org/drawingml/2006/main"/>
           <a:p xmlns:a="http://schemas.openxmlformats.org/drawingml/2006/main">
             <a:pPr algn="l">
+              <a:buNone/>
               <a:defRPr sz="1350" b="1">
                 <a:solidFill>
                   <a:srgbClr val="3D8DFF"/>
@@ -29115,6 +29435,7 @@
           <a:lstStyle xmlns:a="http://schemas.openxmlformats.org/drawingml/2006/main"/>
           <a:p xmlns:a="http://schemas.openxmlformats.org/drawingml/2006/main">
             <a:pPr algn="l">
+              <a:buNone/>
               <a:defRPr sz="1500" b="1">
                 <a:solidFill>
                   <a:srgbClr val="111318"/>
@@ -29167,6 +29488,7 @@
           <a:lstStyle xmlns:a="http://schemas.openxmlformats.org/drawingml/2006/main"/>
           <a:p xmlns:a="http://schemas.openxmlformats.org/drawingml/2006/main">
             <a:pPr algn="l">
+              <a:buNone/>
               <a:defRPr sz="1275" b="0">
                 <a:solidFill>
                   <a:srgbClr val="5E6572"/>
@@ -29314,6 +29636,7 @@
           <a:lstStyle xmlns:a="http://schemas.openxmlformats.org/drawingml/2006/main"/>
           <a:p xmlns:a="http://schemas.openxmlformats.org/drawingml/2006/main">
             <a:pPr algn="l">
+              <a:buNone/>
               <a:defRPr sz="1350" b="1">
                 <a:solidFill>
                   <a:srgbClr val="3D8DFF"/>
@@ -29366,6 +29689,7 @@
           <a:lstStyle xmlns:a="http://schemas.openxmlformats.org/drawingml/2006/main"/>
           <a:p xmlns:a="http://schemas.openxmlformats.org/drawingml/2006/main">
             <a:pPr algn="l">
+              <a:buNone/>
               <a:defRPr sz="1500" b="1">
                 <a:solidFill>
                   <a:srgbClr val="111318"/>
@@ -29418,6 +29742,7 @@
           <a:lstStyle xmlns:a="http://schemas.openxmlformats.org/drawingml/2006/main"/>
           <a:p xmlns:a="http://schemas.openxmlformats.org/drawingml/2006/main">
             <a:pPr algn="l">
+              <a:buNone/>
               <a:defRPr sz="1275" b="0">
                 <a:solidFill>
                   <a:srgbClr val="5E6572"/>
@@ -29565,6 +29890,7 @@
           <a:lstStyle xmlns:a="http://schemas.openxmlformats.org/drawingml/2006/main"/>
           <a:p xmlns:a="http://schemas.openxmlformats.org/drawingml/2006/main">
             <a:pPr algn="l">
+              <a:buNone/>
               <a:defRPr sz="1350" b="1">
                 <a:solidFill>
                   <a:srgbClr val="3D8DFF"/>
@@ -29617,6 +29943,7 @@
           <a:lstStyle xmlns:a="http://schemas.openxmlformats.org/drawingml/2006/main"/>
           <a:p xmlns:a="http://schemas.openxmlformats.org/drawingml/2006/main">
             <a:pPr algn="l">
+              <a:buNone/>
               <a:defRPr sz="1500" b="1">
                 <a:solidFill>
                   <a:srgbClr val="111318"/>
@@ -29669,6 +29996,7 @@
           <a:lstStyle xmlns:a="http://schemas.openxmlformats.org/drawingml/2006/main"/>
           <a:p xmlns:a="http://schemas.openxmlformats.org/drawingml/2006/main">
             <a:pPr algn="l">
+              <a:buNone/>
               <a:defRPr sz="1275" b="0">
                 <a:solidFill>
                   <a:srgbClr val="5E6572"/>
@@ -29816,6 +30144,7 @@
           <a:lstStyle xmlns:a="http://schemas.openxmlformats.org/drawingml/2006/main"/>
           <a:p xmlns:a="http://schemas.openxmlformats.org/drawingml/2006/main">
             <a:pPr algn="l">
+              <a:buNone/>
               <a:defRPr sz="1350" b="1">
                 <a:solidFill>
                   <a:srgbClr val="3D8DFF"/>
@@ -29868,6 +30197,7 @@
           <a:lstStyle xmlns:a="http://schemas.openxmlformats.org/drawingml/2006/main"/>
           <a:p xmlns:a="http://schemas.openxmlformats.org/drawingml/2006/main">
             <a:pPr algn="l">
+              <a:buNone/>
               <a:defRPr sz="1500" b="1">
                 <a:solidFill>
                   <a:srgbClr val="111318"/>
@@ -29920,6 +30250,7 @@
           <a:lstStyle xmlns:a="http://schemas.openxmlformats.org/drawingml/2006/main"/>
           <a:p xmlns:a="http://schemas.openxmlformats.org/drawingml/2006/main">
             <a:pPr algn="l">
+              <a:buNone/>
               <a:defRPr sz="1275" b="0">
                 <a:solidFill>
                   <a:srgbClr val="5E6572"/>
@@ -29972,6 +30303,7 @@
           <a:lstStyle xmlns:a="http://schemas.openxmlformats.org/drawingml/2006/main"/>
           <a:p xmlns:a="http://schemas.openxmlformats.org/drawingml/2006/main">
             <a:pPr algn="l">
+              <a:buNone/>
               <a:defRPr sz="1425" b="1">
                 <a:solidFill>
                   <a:srgbClr val="3D8DFF"/>
@@ -30024,6 +30356,7 @@
           <a:lstStyle xmlns:a="http://schemas.openxmlformats.org/drawingml/2006/main"/>
           <a:p xmlns:a="http://schemas.openxmlformats.org/drawingml/2006/main">
             <a:pPr algn="l">
+              <a:buNone/>
               <a:defRPr sz="1650" b="1">
                 <a:solidFill>
                   <a:srgbClr val="111318"/>
@@ -30076,6 +30409,7 @@
           <a:lstStyle xmlns:a="http://schemas.openxmlformats.org/drawingml/2006/main"/>
           <a:p xmlns:a="http://schemas.openxmlformats.org/drawingml/2006/main">
             <a:pPr algn="l">
+              <a:buNone/>
               <a:defRPr sz="1200" b="0">
                 <a:solidFill>
                   <a:srgbClr val="8F96A3"/>
@@ -30157,6 +30491,7 @@
           <a:lstStyle xmlns:a="http://schemas.openxmlformats.org/drawingml/2006/main"/>
           <a:p xmlns:a="http://schemas.openxmlformats.org/drawingml/2006/main">
             <a:pPr algn="l">
+              <a:buNone/>
               <a:defRPr sz="975" b="1">
                 <a:solidFill>
                   <a:srgbClr val="3D8DFF"/>
@@ -30209,6 +30544,7 @@
           <a:lstStyle xmlns:a="http://schemas.openxmlformats.org/drawingml/2006/main"/>
           <a:p xmlns:a="http://schemas.openxmlformats.org/drawingml/2006/main">
             <a:pPr algn="l">
+              <a:buNone/>
               <a:defRPr sz="3000" b="1">
                 <a:solidFill>
                   <a:srgbClr val="111318"/>
@@ -30292,6 +30628,7 @@
           <a:lstStyle xmlns:a="http://schemas.openxmlformats.org/drawingml/2006/main"/>
           <a:p xmlns:a="http://schemas.openxmlformats.org/drawingml/2006/main">
             <a:pPr algn="r">
+              <a:buNone/>
               <a:defRPr sz="975" b="0">
                 <a:solidFill>
                   <a:srgbClr val="8F96A3"/>
@@ -30377,6 +30714,7 @@
           <a:lstStyle xmlns:a="http://schemas.openxmlformats.org/drawingml/2006/main"/>
           <a:p xmlns:a="http://schemas.openxmlformats.org/drawingml/2006/main">
             <a:pPr algn="l">
+              <a:buNone/>
               <a:defRPr sz="2400" b="1">
                 <a:solidFill>
                   <a:srgbClr val="3D8DFF"/>
@@ -30429,6 +30767,7 @@
           <a:lstStyle xmlns:a="http://schemas.openxmlformats.org/drawingml/2006/main"/>
           <a:p xmlns:a="http://schemas.openxmlformats.org/drawingml/2006/main">
             <a:pPr algn="l">
+              <a:buNone/>
               <a:defRPr sz="1650" b="1">
                 <a:solidFill>
                   <a:srgbClr val="111318"/>
@@ -30481,6 +30820,7 @@
           <a:lstStyle xmlns:a="http://schemas.openxmlformats.org/drawingml/2006/main"/>
           <a:p xmlns:a="http://schemas.openxmlformats.org/drawingml/2006/main">
             <a:pPr algn="l">
+              <a:buNone/>
               <a:defRPr sz="1125" b="1">
                 <a:solidFill>
                   <a:srgbClr val="3D8DFF"/>
@@ -30533,6 +30873,7 @@
           <a:lstStyle xmlns:a="http://schemas.openxmlformats.org/drawingml/2006/main"/>
           <a:p xmlns:a="http://schemas.openxmlformats.org/drawingml/2006/main">
             <a:pPr algn="l">
+              <a:buNone/>
               <a:defRPr sz="1350" b="0">
                 <a:solidFill>
                   <a:srgbClr val="5E6572"/>
@@ -30585,6 +30926,7 @@
           <a:lstStyle xmlns:a="http://schemas.openxmlformats.org/drawingml/2006/main"/>
           <a:p xmlns:a="http://schemas.openxmlformats.org/drawingml/2006/main">
             <a:pPr algn="ctr">
+              <a:buNone/>
               <a:defRPr sz="2100" b="1">
                 <a:solidFill>
                   <a:srgbClr val="3D8DFF"/>
@@ -30637,6 +30979,7 @@
           <a:lstStyle xmlns:a="http://schemas.openxmlformats.org/drawingml/2006/main"/>
           <a:p xmlns:a="http://schemas.openxmlformats.org/drawingml/2006/main">
             <a:pPr algn="l">
+              <a:buNone/>
               <a:defRPr sz="1350" b="1">
                 <a:solidFill>
                   <a:srgbClr val="111318"/>
@@ -30722,6 +31065,7 @@
           <a:lstStyle xmlns:a="http://schemas.openxmlformats.org/drawingml/2006/main"/>
           <a:p xmlns:a="http://schemas.openxmlformats.org/drawingml/2006/main">
             <a:pPr algn="l">
+              <a:buNone/>
               <a:defRPr sz="2400" b="1">
                 <a:solidFill>
                   <a:srgbClr val="2D9D78"/>
@@ -30774,6 +31118,7 @@
           <a:lstStyle xmlns:a="http://schemas.openxmlformats.org/drawingml/2006/main"/>
           <a:p xmlns:a="http://schemas.openxmlformats.org/drawingml/2006/main">
             <a:pPr algn="l">
+              <a:buNone/>
               <a:defRPr sz="1650" b="1">
                 <a:solidFill>
                   <a:srgbClr val="111318"/>
@@ -30826,6 +31171,7 @@
           <a:lstStyle xmlns:a="http://schemas.openxmlformats.org/drawingml/2006/main"/>
           <a:p xmlns:a="http://schemas.openxmlformats.org/drawingml/2006/main">
             <a:pPr algn="l">
+              <a:buNone/>
               <a:defRPr sz="1125" b="1">
                 <a:solidFill>
                   <a:srgbClr val="2D9D78"/>
@@ -30878,6 +31224,7 @@
           <a:lstStyle xmlns:a="http://schemas.openxmlformats.org/drawingml/2006/main"/>
           <a:p xmlns:a="http://schemas.openxmlformats.org/drawingml/2006/main">
             <a:pPr algn="l">
+              <a:buNone/>
               <a:defRPr sz="1350" b="0">
                 <a:solidFill>
                   <a:srgbClr val="5E6572"/>
@@ -30930,6 +31277,7 @@
           <a:lstStyle xmlns:a="http://schemas.openxmlformats.org/drawingml/2006/main"/>
           <a:p xmlns:a="http://schemas.openxmlformats.org/drawingml/2006/main">
             <a:pPr algn="ctr">
+              <a:buNone/>
               <a:defRPr sz="2100" b="1">
                 <a:solidFill>
                   <a:srgbClr val="2D9D78"/>
@@ -30982,6 +31330,7 @@
           <a:lstStyle xmlns:a="http://schemas.openxmlformats.org/drawingml/2006/main"/>
           <a:p xmlns:a="http://schemas.openxmlformats.org/drawingml/2006/main">
             <a:pPr algn="l">
+              <a:buNone/>
               <a:defRPr sz="1350" b="1">
                 <a:solidFill>
                   <a:srgbClr val="111318"/>
@@ -31067,6 +31416,7 @@
           <a:lstStyle xmlns:a="http://schemas.openxmlformats.org/drawingml/2006/main"/>
           <a:p xmlns:a="http://schemas.openxmlformats.org/drawingml/2006/main">
             <a:pPr algn="l">
+              <a:buNone/>
               <a:defRPr sz="2400" b="1">
                 <a:solidFill>
                   <a:srgbClr val="E59A2F"/>
@@ -31119,6 +31469,7 @@
           <a:lstStyle xmlns:a="http://schemas.openxmlformats.org/drawingml/2006/main"/>
           <a:p xmlns:a="http://schemas.openxmlformats.org/drawingml/2006/main">
             <a:pPr algn="l">
+              <a:buNone/>
               <a:defRPr sz="1650" b="1">
                 <a:solidFill>
                   <a:srgbClr val="111318"/>
@@ -31171,6 +31522,7 @@
           <a:lstStyle xmlns:a="http://schemas.openxmlformats.org/drawingml/2006/main"/>
           <a:p xmlns:a="http://schemas.openxmlformats.org/drawingml/2006/main">
             <a:pPr algn="l">
+              <a:buNone/>
               <a:defRPr sz="1125" b="1">
                 <a:solidFill>
                   <a:srgbClr val="E59A2F"/>
@@ -31223,6 +31575,7 @@
           <a:lstStyle xmlns:a="http://schemas.openxmlformats.org/drawingml/2006/main"/>
           <a:p xmlns:a="http://schemas.openxmlformats.org/drawingml/2006/main">
             <a:pPr algn="l">
+              <a:buNone/>
               <a:defRPr sz="1350" b="0">
                 <a:solidFill>
                   <a:srgbClr val="5E6572"/>
@@ -31275,6 +31628,7 @@
           <a:lstStyle xmlns:a="http://schemas.openxmlformats.org/drawingml/2006/main"/>
           <a:p xmlns:a="http://schemas.openxmlformats.org/drawingml/2006/main">
             <a:pPr algn="ctr">
+              <a:buNone/>
               <a:defRPr sz="2100" b="1">
                 <a:solidFill>
                   <a:srgbClr val="E59A2F"/>
@@ -31327,6 +31681,7 @@
           <a:lstStyle xmlns:a="http://schemas.openxmlformats.org/drawingml/2006/main"/>
           <a:p xmlns:a="http://schemas.openxmlformats.org/drawingml/2006/main">
             <a:pPr algn="l">
+              <a:buNone/>
               <a:defRPr sz="1350" b="1">
                 <a:solidFill>
                   <a:srgbClr val="111318"/>

</xml_diff>